<commit_message>
fix(k6): correct VU memory and MCP tool claims in Ch1/Ch6 slides
- Clarify k6 VU footprint (~1–5MB per VU; goroutine itself ~2KB) vs Java thread
- Describe validate_script as a 1-VU/1-iteration run, not AST static check
- Note run_script limits (50 VUs, 5 min) and replace retired test.k6.io URL
- Regenerate Ch6 slide images and pptx decks

Co-Authored-By: Claude Opus 5.5 <noreply@anthropic.com>
</commit_message>
<xml_diff>
--- a/k6/slides/Ch6_k6_AI_Agent_Engineering.pptx
+++ b/k6/slides/Ch6_k6_AI_Agent_Engineering.pptx
@@ -11394,7 +11394,7 @@
                 <a:cs typeface="Noto Sans"/>
                 <a:sym typeface="Noto Sans"/>
               </a:rPr>
-              <a:t>k6 x agent 專為工程自動化而生：單一命令自動完成「安裝 5 大 AI 技能包」與「註冊 k6 MCP 伺服器」，秒級打通 AI 助手！</a:t>
+              <a:t>k6 x agent 專為工程自動化而生：單一命令自動完成「安裝 11 個 AI 技能包」與「註冊 k6 MCP 伺服器」，秒級打通 AI 助手！</a:t>
             </a:r>
             <a:endParaRPr b="1" sz="1050">
               <a:solidFill>
@@ -11541,7 +11541,7 @@
                 <a:cs typeface="Noto Sans"/>
                 <a:sym typeface="Noto Sans"/>
               </a:rPr>
-              <a:t>5 大 Bundled Skills</a:t>
+              <a:t>11 個 Bundled Skills</a:t>
             </a:r>
             <a:endParaRPr b="1" sz="1000">
               <a:solidFill>
@@ -12009,7 +12009,7 @@
                 <a:cs typeface="Noto Sans"/>
                 <a:sym typeface="Noto Sans"/>
               </a:rPr>
-              <a:t>AST 靜態語法預檢：</a:t>
+              <a:t>1 VU 冒煙預檢：</a:t>
             </a:r>
             <a:r>
               <a:rPr b="0" lang="en-US" sz="950">
@@ -12021,7 +12021,7 @@
                 <a:cs typeface="Noto Sans"/>
                 <a:sym typeface="Noto Sans"/>
               </a:rPr>
-              <a:t>提供 validate_script 工具，執行前預檢抓出語法瑕疵與未宣告變數。</a:t>
+              <a:t>提供 validate_script 工具，以 1 VU 實際執行，抓出語法與執行期錯誤。</a:t>
             </a:r>
             <a:endParaRPr b="1" sz="1000">
               <a:solidFill>
@@ -12077,7 +12077,7 @@
                 <a:cs typeface="Noto Sans"/>
                 <a:sym typeface="Noto Sans"/>
               </a:rPr>
-              <a:t>提供 run_script 工具，直接由本機跑通 1 VU 冒煙驗證與報錯自主修復。</a:t>
+              <a:t>提供 run_script 工具，直接由本機執行壓測並依報錯自主修復。</a:t>
             </a:r>
             <a:endParaRPr b="1" sz="1000">
               <a:solidFill>
@@ -12680,7 +12680,7 @@
                 <a:cs typeface="Noto Sans"/>
                 <a:sym typeface="Noto Sans"/>
               </a:rPr>
-              <a:t>接下來我們將依序深入架構雙引擎、安全冪等性、CLI 指令速查、5 大專業技能與企業導入實務！</a:t>
+              <a:t>接下來我們將依序深入架構雙引擎、安全冪等性、CLI 指令速查、11 個技能（精講 5 大）與企業導入實務！</a:t>
             </a:r>
             <a:endParaRPr b="0" sz="1000">
               <a:solidFill>
@@ -12721,95 +12721,6 @@
           </a:ln>
         </p:spPr>
       </p:pic>
-      <p:sp>
-        <p:nvSpPr>
-          <p:cNvPr id="98" name="Google Shape;98;p1">
-            <a:hlinkClick r:id="rId4"/>
-          </p:cNvPr>
-          <p:cNvSpPr/>
-          <p:nvPr/>
-        </p:nvSpPr>
-        <p:spPr>
-          <a:xfrm>
-            <a:off x="666750" y="8591550"/>
-            <a:ext cx="6039000" cy="247800"/>
-          </a:xfrm>
-          <a:prstGeom prst="roundRect">
-            <a:avLst>
-              <a:gd fmla="val 23076" name="adj"/>
-            </a:avLst>
-          </a:prstGeom>
-          <a:solidFill>
-            <a:srgbClr val="FFFFFF"/>
-          </a:solidFill>
-          <a:ln cap="flat" cmpd="sng" w="9525">
-            <a:solidFill>
-              <a:srgbClr val="CBD5E1"/>
-            </a:solidFill>
-            <a:prstDash val="solid"/>
-            <a:round/>
-            <a:headEnd len="sm" w="sm" type="none"/>
-            <a:tailEnd len="sm" w="sm" type="none"/>
-          </a:ln>
-          <a:effectLst>
-            <a:outerShdw blurRad="40000" rotWithShape="0" dir="5400000" dist="23000">
-              <a:srgbClr val="000000">
-                <a:alpha val="34902"/>
-              </a:srgbClr>
-            </a:outerShdw>
-          </a:effectLst>
-        </p:spPr>
-        <p:txBody>
-          <a:bodyPr anchorCtr="0" anchor="ctr" bIns="0" lIns="114300" spcFirstLastPara="1" rIns="114300" wrap="square" tIns="0">
-            <a:noAutofit/>
-          </a:bodyPr>
-          <a:lstStyle/>
-          <a:p>
-            <a:pPr indent="0" lvl="0" marL="0" rtl="0" algn="l">
-              <a:spcBef>
-                <a:spcPts val="0"/>
-              </a:spcBef>
-              <a:spcAft>
-                <a:spcPts val="0"/>
-              </a:spcAft>
-              <a:buNone/>
-            </a:pPr>
-            <a:r>
-              <a:rPr b="1" lang="en-US" sz="900">
-                <a:solidFill>
-                  <a:srgbClr val="0F172A"/>
-                </a:solidFill>
-                <a:latin typeface="Noto Sans"/>
-                <a:ea typeface="Noto Sans"/>
-                <a:cs typeface="Noto Sans"/>
-                <a:sym typeface="Noto Sans"/>
-              </a:rPr>
-              <a:t>▶ 課程實戰 Codelabs：</a:t>
-            </a:r>
-            <a:r>
-              <a:rPr b="0" lang="en-US" sz="900">
-                <a:solidFill>
-                  <a:srgbClr val="2563EB"/>
-                </a:solidFill>
-                <a:latin typeface="Noto Sans"/>
-                <a:ea typeface="Noto Sans"/>
-                <a:cs typeface="Noto Sans"/>
-                <a:sym typeface="Noto Sans"/>
-              </a:rPr>
-              <a:t>tedmax100.github.io/o11y_lab_for_dummies/k6-performance-testing/</a:t>
-            </a:r>
-            <a:endParaRPr b="1" sz="900">
-              <a:solidFill>
-                <a:srgbClr val="0F172A"/>
-              </a:solidFill>
-              <a:latin typeface="Noto Sans"/>
-              <a:ea typeface="Noto Sans"/>
-              <a:cs typeface="Noto Sans"/>
-              <a:sym typeface="Noto Sans"/>
-            </a:endParaRPr>
-          </a:p>
-        </p:txBody>
-      </p:sp>
       <p:sp>
         <p:nvSpPr>
           <p:cNvPr id="99" name="Codelabs_Link_Badge">
@@ -14265,87 +14176,6 @@
       </p:sp>
       <p:sp>
         <p:nvSpPr>
-          <p:cNvPr id="128" name="Google Shape;128;p2">
-            <a:hlinkClick r:id="rId4"/>
-          </p:cNvPr>
-          <p:cNvSpPr/>
-          <p:nvPr/>
-        </p:nvSpPr>
-        <p:spPr>
-          <a:xfrm>
-            <a:off x="502920" y="8869680"/>
-            <a:ext cx="6035100" cy="219600"/>
-          </a:xfrm>
-          <a:prstGeom prst="roundRect">
-            <a:avLst>
-              <a:gd fmla="val 16667" name="adj"/>
-            </a:avLst>
-          </a:prstGeom>
-          <a:solidFill>
-            <a:srgbClr val="FFFFFF"/>
-          </a:solidFill>
-          <a:ln cap="flat" cmpd="sng" w="12700">
-            <a:solidFill>
-              <a:srgbClr val="E2E8F0"/>
-            </a:solidFill>
-            <a:prstDash val="solid"/>
-            <a:round/>
-            <a:headEnd len="sm" w="sm" type="none"/>
-            <a:tailEnd len="sm" w="sm" type="none"/>
-          </a:ln>
-          <a:effectLst>
-            <a:outerShdw blurRad="40000" rotWithShape="0" dir="5400000" dist="23000">
-              <a:srgbClr val="000000">
-                <a:alpha val="34902"/>
-              </a:srgbClr>
-            </a:outerShdw>
-          </a:effectLst>
-        </p:spPr>
-        <p:txBody>
-          <a:bodyPr anchorCtr="0" anchor="ctr" bIns="0" lIns="109725" spcFirstLastPara="1" rIns="109725" wrap="square" tIns="0">
-            <a:noAutofit/>
-          </a:bodyPr>
-          <a:lstStyle/>
-          <a:p>
-            <a:pPr indent="0" lvl="0" marL="0" marR="0" rtl="0" algn="l">
-              <a:spcBef>
-                <a:spcPts val="0"/>
-              </a:spcBef>
-              <a:spcAft>
-                <a:spcPts val="0"/>
-              </a:spcAft>
-              <a:buNone/>
-            </a:pPr>
-            <a:r>
-              <a:rPr b="1" i="0" lang="en-US" sz="850" u="none" cap="none" strike="noStrike">
-                <a:solidFill>
-                  <a:srgbClr val="1E293B"/>
-                </a:solidFill>
-                <a:latin typeface="Noto Sans"/>
-                <a:ea typeface="Noto Sans"/>
-                <a:cs typeface="Noto Sans"/>
-                <a:sym typeface="Noto Sans"/>
-              </a:rPr>
-              <a:t>▶ 課程實戰 Codelabs：</a:t>
-            </a:r>
-            <a:r>
-              <a:rPr b="0" i="0" lang="en-US" sz="850" u="none" cap="none" strike="noStrike">
-                <a:solidFill>
-                  <a:srgbClr val="2563EB"/>
-                </a:solidFill>
-                <a:latin typeface="Noto Sans"/>
-                <a:ea typeface="Noto Sans"/>
-                <a:cs typeface="Noto Sans"/>
-                <a:sym typeface="Noto Sans"/>
-              </a:rPr>
-              <a:t>tedmax100.github.io/o11y_lab_for_dummies/k6-performance-testing/</a:t>
-            </a:r>
-            <a:endParaRPr/>
-          </a:p>
-        </p:txBody>
-      </p:sp>
-      <p:sp>
-        <p:nvSpPr>
           <p:cNvPr id="129" name="Google Shape;129;p2"/>
           <p:cNvSpPr txBox="1"/>
           <p:nvPr/>
@@ -14436,7 +14266,7 @@
                 <a:cs typeface="Noto Sans"/>
                 <a:sym typeface="Noto Sans"/>
               </a:rPr>
-              <a:t>賦予 AI 助手即時語法靜態預檢與本機壓測自癒執行力</a:t>
+              <a:t>賦予 AI 助手 1 VU 冒煙預檢與本機壓測自癒執行力</a:t>
             </a:r>
             <a:endParaRPr b="0" sz="1050">
               <a:solidFill>
@@ -16962,87 +16792,6 @@
       </p:pic>
       <p:sp>
         <p:nvSpPr>
-          <p:cNvPr id="165" name="Google Shape;165;p3">
-            <a:hlinkClick r:id="rId4"/>
-          </p:cNvPr>
-          <p:cNvSpPr/>
-          <p:nvPr/>
-        </p:nvSpPr>
-        <p:spPr>
-          <a:xfrm>
-            <a:off x="502920" y="8869680"/>
-            <a:ext cx="6035100" cy="219600"/>
-          </a:xfrm>
-          <a:prstGeom prst="roundRect">
-            <a:avLst>
-              <a:gd fmla="val 16667" name="adj"/>
-            </a:avLst>
-          </a:prstGeom>
-          <a:solidFill>
-            <a:srgbClr val="FFFFFF"/>
-          </a:solidFill>
-          <a:ln cap="flat" cmpd="sng" w="12700">
-            <a:solidFill>
-              <a:srgbClr val="E2E8F0"/>
-            </a:solidFill>
-            <a:prstDash val="solid"/>
-            <a:round/>
-            <a:headEnd len="sm" w="sm" type="none"/>
-            <a:tailEnd len="sm" w="sm" type="none"/>
-          </a:ln>
-          <a:effectLst>
-            <a:outerShdw blurRad="40000" rotWithShape="0" dir="5400000" dist="23000">
-              <a:srgbClr val="000000">
-                <a:alpha val="34902"/>
-              </a:srgbClr>
-            </a:outerShdw>
-          </a:effectLst>
-        </p:spPr>
-        <p:txBody>
-          <a:bodyPr anchorCtr="0" anchor="ctr" bIns="0" lIns="109725" spcFirstLastPara="1" rIns="109725" wrap="square" tIns="0">
-            <a:noAutofit/>
-          </a:bodyPr>
-          <a:lstStyle/>
-          <a:p>
-            <a:pPr indent="0" lvl="0" marL="0" marR="0" rtl="0" algn="l">
-              <a:spcBef>
-                <a:spcPts val="0"/>
-              </a:spcBef>
-              <a:spcAft>
-                <a:spcPts val="0"/>
-              </a:spcAft>
-              <a:buNone/>
-            </a:pPr>
-            <a:r>
-              <a:rPr b="1" i="0" lang="en-US" sz="850" u="none" cap="none" strike="noStrike">
-                <a:solidFill>
-                  <a:srgbClr val="1E293B"/>
-                </a:solidFill>
-                <a:latin typeface="Noto Sans"/>
-                <a:ea typeface="Noto Sans"/>
-                <a:cs typeface="Noto Sans"/>
-                <a:sym typeface="Noto Sans"/>
-              </a:rPr>
-              <a:t>▶ 課程實戰 Codelabs：</a:t>
-            </a:r>
-            <a:r>
-              <a:rPr b="0" i="0" lang="en-US" sz="850" u="none" cap="none" strike="noStrike">
-                <a:solidFill>
-                  <a:srgbClr val="2563EB"/>
-                </a:solidFill>
-                <a:latin typeface="Noto Sans"/>
-                <a:ea typeface="Noto Sans"/>
-                <a:cs typeface="Noto Sans"/>
-                <a:sym typeface="Noto Sans"/>
-              </a:rPr>
-              <a:t>tedmax100.github.io/o11y_lab_for_dummies/k6-performance-testing/</a:t>
-            </a:r>
-            <a:endParaRPr/>
-          </a:p>
-        </p:txBody>
-      </p:sp>
-      <p:sp>
-        <p:nvSpPr>
           <p:cNvPr id="166" name="Codelabs_Link_Badge">
             <a:hlinkClick r:id="rId4"/>
           </p:cNvPr>
@@ -19374,95 +19123,6 @@
       </p:pic>
       <p:sp>
         <p:nvSpPr>
-          <p:cNvPr id="197" name="Google Shape;197;p4">
-            <a:hlinkClick r:id="rId5"/>
-          </p:cNvPr>
-          <p:cNvSpPr/>
-          <p:nvPr/>
-        </p:nvSpPr>
-        <p:spPr>
-          <a:xfrm>
-            <a:off x="502920" y="8839200"/>
-            <a:ext cx="6035100" cy="219600"/>
-          </a:xfrm>
-          <a:prstGeom prst="roundRect">
-            <a:avLst>
-              <a:gd fmla="val 16666" name="adj"/>
-            </a:avLst>
-          </a:prstGeom>
-          <a:solidFill>
-            <a:srgbClr val="FFFFFF"/>
-          </a:solidFill>
-          <a:ln cap="flat" cmpd="sng" w="9525">
-            <a:solidFill>
-              <a:srgbClr val="CBD5E1"/>
-            </a:solidFill>
-            <a:prstDash val="solid"/>
-            <a:round/>
-            <a:headEnd len="sm" w="sm" type="none"/>
-            <a:tailEnd len="sm" w="sm" type="none"/>
-          </a:ln>
-          <a:effectLst>
-            <a:outerShdw blurRad="40000" rotWithShape="0" dir="5400000" dist="23000">
-              <a:srgbClr val="000000">
-                <a:alpha val="34902"/>
-              </a:srgbClr>
-            </a:outerShdw>
-          </a:effectLst>
-        </p:spPr>
-        <p:txBody>
-          <a:bodyPr anchorCtr="0" anchor="ctr" bIns="0" lIns="114300" spcFirstLastPara="1" rIns="114300" wrap="square" tIns="0">
-            <a:noAutofit/>
-          </a:bodyPr>
-          <a:lstStyle/>
-          <a:p>
-            <a:pPr indent="0" lvl="0" marL="0" rtl="0" algn="l">
-              <a:spcBef>
-                <a:spcPts val="0"/>
-              </a:spcBef>
-              <a:spcAft>
-                <a:spcPts val="0"/>
-              </a:spcAft>
-              <a:buNone/>
-            </a:pPr>
-            <a:r>
-              <a:rPr b="1" lang="en-US" sz="850">
-                <a:solidFill>
-                  <a:srgbClr val="1E293B"/>
-                </a:solidFill>
-                <a:latin typeface="Noto Sans"/>
-                <a:ea typeface="Noto Sans"/>
-                <a:cs typeface="Noto Sans"/>
-                <a:sym typeface="Noto Sans"/>
-              </a:rPr>
-              <a:t>▶ 課程實戰 Codelabs：</a:t>
-            </a:r>
-            <a:r>
-              <a:rPr b="0" lang="en-US" sz="850">
-                <a:solidFill>
-                  <a:srgbClr val="2563EB"/>
-                </a:solidFill>
-                <a:latin typeface="Noto Sans"/>
-                <a:ea typeface="Noto Sans"/>
-                <a:cs typeface="Noto Sans"/>
-                <a:sym typeface="Noto Sans"/>
-              </a:rPr>
-              <a:t>tedmax100.github.io/o11y_lab_for_dummies/k6-performance-testing/</a:t>
-            </a:r>
-            <a:endParaRPr b="1" sz="850">
-              <a:solidFill>
-                <a:srgbClr val="1E293B"/>
-              </a:solidFill>
-              <a:latin typeface="Noto Sans"/>
-              <a:ea typeface="Noto Sans"/>
-              <a:cs typeface="Noto Sans"/>
-              <a:sym typeface="Noto Sans"/>
-            </a:endParaRPr>
-          </a:p>
-        </p:txBody>
-      </p:sp>
-      <p:sp>
-        <p:nvSpPr>
           <p:cNvPr id="198" name="Codelabs_Link_Badge">
             <a:hlinkClick r:id="rId5"/>
           </p:cNvPr>
@@ -19653,7 +19313,7 @@
                 <a:cs typeface="Noto Sans"/>
                 <a:sym typeface="Noto Sans"/>
               </a:rPr>
-              <a:t>內建 5 大 AI 技能深度剖析：專家級壓測工作流</a:t>
+              <a:t>11 個技能精講 5 大：專家級壓測核心工作流</a:t>
             </a:r>
             <a:endParaRPr/>
           </a:p>
@@ -20992,87 +20652,6 @@
           </a:ln>
         </p:spPr>
       </p:pic>
-      <p:sp>
-        <p:nvSpPr>
-          <p:cNvPr id="220" name="Google Shape;220;p5">
-            <a:hlinkClick r:id="rId4"/>
-          </p:cNvPr>
-          <p:cNvSpPr/>
-          <p:nvPr/>
-        </p:nvSpPr>
-        <p:spPr>
-          <a:xfrm>
-            <a:off x="502920" y="8869680"/>
-            <a:ext cx="6035040" cy="219456"/>
-          </a:xfrm>
-          <a:prstGeom prst="roundRect">
-            <a:avLst>
-              <a:gd fmla="val 16667" name="adj"/>
-            </a:avLst>
-          </a:prstGeom>
-          <a:solidFill>
-            <a:srgbClr val="FFFFFF"/>
-          </a:solidFill>
-          <a:ln cap="flat" cmpd="sng" w="12700">
-            <a:solidFill>
-              <a:srgbClr val="E2E8F0"/>
-            </a:solidFill>
-            <a:prstDash val="solid"/>
-            <a:round/>
-            <a:headEnd len="sm" w="sm" type="none"/>
-            <a:tailEnd len="sm" w="sm" type="none"/>
-          </a:ln>
-          <a:effectLst>
-            <a:outerShdw blurRad="40000" rotWithShape="0" dir="5400000" dist="23000">
-              <a:srgbClr val="000000">
-                <a:alpha val="34902"/>
-              </a:srgbClr>
-            </a:outerShdw>
-          </a:effectLst>
-        </p:spPr>
-        <p:txBody>
-          <a:bodyPr anchorCtr="0" anchor="ctr" bIns="0" lIns="109725" spcFirstLastPara="1" rIns="109725" wrap="square" tIns="0">
-            <a:noAutofit/>
-          </a:bodyPr>
-          <a:lstStyle/>
-          <a:p>
-            <a:pPr indent="0" lvl="0" marL="0" marR="0" rtl="0" algn="l">
-              <a:spcBef>
-                <a:spcPts val="0"/>
-              </a:spcBef>
-              <a:spcAft>
-                <a:spcPts val="0"/>
-              </a:spcAft>
-              <a:buNone/>
-            </a:pPr>
-            <a:r>
-              <a:rPr b="1" i="0" lang="en-US" sz="850" u="none" cap="none" strike="noStrike">
-                <a:solidFill>
-                  <a:srgbClr val="1E293B"/>
-                </a:solidFill>
-                <a:latin typeface="Noto Sans"/>
-                <a:ea typeface="Noto Sans"/>
-                <a:cs typeface="Noto Sans"/>
-                <a:sym typeface="Noto Sans"/>
-              </a:rPr>
-              <a:t>▶ 課程實戰 Codelabs：</a:t>
-            </a:r>
-            <a:r>
-              <a:rPr b="0" i="0" lang="en-US" sz="850" u="none" cap="none" strike="noStrike">
-                <a:solidFill>
-                  <a:srgbClr val="2563EB"/>
-                </a:solidFill>
-                <a:latin typeface="Noto Sans"/>
-                <a:ea typeface="Noto Sans"/>
-                <a:cs typeface="Noto Sans"/>
-                <a:sym typeface="Noto Sans"/>
-              </a:rPr>
-              <a:t>tedmax100.github.io/o11y_lab_for_dummies/k6-performance-testing/</a:t>
-            </a:r>
-            <a:endParaRPr/>
-          </a:p>
-        </p:txBody>
-      </p:sp>
       <p:sp>
         <p:nvSpPr>
           <p:cNvPr id="221" name="Codelabs_Link_Badge">
@@ -21885,7 +21464,7 @@
                 <a:cs typeface="Noto Sans"/>
                 <a:sym typeface="Noto Sans"/>
               </a:rPr>
-              <a:t>• AST 靜態語法預檢：</a:t>
+              <a:t>• 1 VU 冒煙預檢：</a:t>
             </a:r>
             <a:r>
               <a:rPr lang="en-US" sz="1000">
@@ -21897,7 +21476,7 @@
                 <a:cs typeface="Noto Sans"/>
                 <a:sym typeface="Noto Sans"/>
               </a:rPr>
-              <a:t>生成腳本後，AI 必須自動調用 validate_script 抓出未定義變數與生命週期錯誤。</a:t>
+              <a:t>生成腳本後，AI 必須自動調用 validate_script 以 1 VU 實跑，抓出語法與執行期錯誤。</a:t>
             </a:r>
             <a:endParaRPr sz="1000">
               <a:solidFill>
@@ -22966,95 +22545,6 @@
           </a:ln>
         </p:spPr>
       </p:pic>
-      <p:sp>
-        <p:nvSpPr>
-          <p:cNvPr id="243" name="Google Shape;243;p6">
-            <a:hlinkClick r:id="rId6"/>
-          </p:cNvPr>
-          <p:cNvSpPr/>
-          <p:nvPr/>
-        </p:nvSpPr>
-        <p:spPr>
-          <a:xfrm>
-            <a:off x="666750" y="8743950"/>
-            <a:ext cx="6096000" cy="228600"/>
-          </a:xfrm>
-          <a:prstGeom prst="roundRect">
-            <a:avLst>
-              <a:gd fmla="val 50000" name="adj"/>
-            </a:avLst>
-          </a:prstGeom>
-          <a:solidFill>
-            <a:srgbClr val="FFFFFF"/>
-          </a:solidFill>
-          <a:ln cap="flat" cmpd="sng" w="9525">
-            <a:solidFill>
-              <a:srgbClr val="E2E8F0"/>
-            </a:solidFill>
-            <a:prstDash val="solid"/>
-            <a:round/>
-            <a:headEnd len="sm" w="sm" type="none"/>
-            <a:tailEnd len="sm" w="sm" type="none"/>
-          </a:ln>
-          <a:effectLst>
-            <a:outerShdw blurRad="40000" rotWithShape="0" dir="5400000" dist="23000">
-              <a:srgbClr val="000000">
-                <a:alpha val="34902"/>
-              </a:srgbClr>
-            </a:outerShdw>
-          </a:effectLst>
-        </p:spPr>
-        <p:txBody>
-          <a:bodyPr anchorCtr="0" anchor="ctr" bIns="0" lIns="133350" spcFirstLastPara="1" rIns="0" wrap="square" tIns="0">
-            <a:noAutofit/>
-          </a:bodyPr>
-          <a:lstStyle/>
-          <a:p>
-            <a:pPr indent="0" lvl="0" marL="0" rtl="0" algn="l">
-              <a:spcBef>
-                <a:spcPts val="0"/>
-              </a:spcBef>
-              <a:spcAft>
-                <a:spcPts val="0"/>
-              </a:spcAft>
-              <a:buNone/>
-            </a:pPr>
-            <a:r>
-              <a:rPr b="1" lang="en-US" sz="850">
-                <a:solidFill>
-                  <a:srgbClr val="0F172A"/>
-                </a:solidFill>
-                <a:latin typeface="Noto Sans"/>
-                <a:ea typeface="Noto Sans"/>
-                <a:cs typeface="Noto Sans"/>
-                <a:sym typeface="Noto Sans"/>
-              </a:rPr>
-              <a:t>▶ 課程實戰 Codelabs：</a:t>
-            </a:r>
-            <a:r>
-              <a:rPr b="0" lang="en-US" sz="850">
-                <a:solidFill>
-                  <a:srgbClr val="2563EB"/>
-                </a:solidFill>
-                <a:latin typeface="Noto Sans"/>
-                <a:ea typeface="Noto Sans"/>
-                <a:cs typeface="Noto Sans"/>
-                <a:sym typeface="Noto Sans"/>
-              </a:rPr>
-              <a:t>tedmax100.github.io/o11y_lab_for_dummies/k6-performance-testing/</a:t>
-            </a:r>
-            <a:endParaRPr b="1" sz="850">
-              <a:solidFill>
-                <a:srgbClr val="0F172A"/>
-              </a:solidFill>
-              <a:latin typeface="Noto Sans"/>
-              <a:ea typeface="Noto Sans"/>
-              <a:cs typeface="Noto Sans"/>
-              <a:sym typeface="Noto Sans"/>
-            </a:endParaRPr>
-          </a:p>
-        </p:txBody>
-      </p:sp>
       <p:sp>
         <p:nvSpPr>
           <p:cNvPr id="244" name="Codelabs_Link_Badge">
@@ -23884,7 +23374,7 @@
                       <a:cs typeface="Verdana"/>
                       <a:sym typeface="Verdana"/>
                     </a:rPr>
-                    <a:t># 檢查 MCP 伺服器連線狀態與 5 大技能清單</a:t>
+                    <a:t># 檢查 MCP 伺服器連線狀態與 11 個技能清單</a:t>
                   </a:r>
                   <a:endParaRPr sz="800">
                     <a:solidFill>
@@ -24040,7 +23530,7 @@
                       <a:cs typeface="Noto Sans"/>
                       <a:sym typeface="Noto Sans"/>
                     </a:rPr>
-                    <a:t>.cursor/rules/ 下成功產生 5 個 .mdc 規則檔，且 .cursor/mcp.json 正確註冊 k6 x mcp。</a:t>
+                    <a:t>.cursor/rules/ 下成功產生 11 個 .mdc 規則檔，且 .cursor/mcp.json 正確註冊 k6 x mcp。</a:t>
                   </a:r>
                   <a:endParaRPr sz="900">
                     <a:solidFill>
@@ -25586,87 +25076,6 @@
           </a:ln>
         </p:spPr>
       </p:pic>
-      <p:sp>
-        <p:nvSpPr>
-          <p:cNvPr id="294" name="Google Shape;294;p7">
-            <a:hlinkClick r:id="rId4"/>
-          </p:cNvPr>
-          <p:cNvSpPr/>
-          <p:nvPr/>
-        </p:nvSpPr>
-        <p:spPr>
-          <a:xfrm>
-            <a:off x="502920" y="8869680"/>
-            <a:ext cx="6035100" cy="219600"/>
-          </a:xfrm>
-          <a:prstGeom prst="roundRect">
-            <a:avLst>
-              <a:gd fmla="val 16667" name="adj"/>
-            </a:avLst>
-          </a:prstGeom>
-          <a:solidFill>
-            <a:srgbClr val="FFFFFF"/>
-          </a:solidFill>
-          <a:ln cap="flat" cmpd="sng" w="12700">
-            <a:solidFill>
-              <a:srgbClr val="E2E8F0"/>
-            </a:solidFill>
-            <a:prstDash val="solid"/>
-            <a:round/>
-            <a:headEnd len="sm" w="sm" type="none"/>
-            <a:tailEnd len="sm" w="sm" type="none"/>
-          </a:ln>
-          <a:effectLst>
-            <a:outerShdw blurRad="40000" rotWithShape="0" dir="5400000" dist="23000">
-              <a:srgbClr val="000000">
-                <a:alpha val="34902"/>
-              </a:srgbClr>
-            </a:outerShdw>
-          </a:effectLst>
-        </p:spPr>
-        <p:txBody>
-          <a:bodyPr anchorCtr="0" anchor="ctr" bIns="0" lIns="109725" spcFirstLastPara="1" rIns="109725" wrap="square" tIns="0">
-            <a:noAutofit/>
-          </a:bodyPr>
-          <a:lstStyle/>
-          <a:p>
-            <a:pPr indent="0" lvl="0" marL="0" marR="0" rtl="0" algn="l">
-              <a:spcBef>
-                <a:spcPts val="0"/>
-              </a:spcBef>
-              <a:spcAft>
-                <a:spcPts val="0"/>
-              </a:spcAft>
-              <a:buNone/>
-            </a:pPr>
-            <a:r>
-              <a:rPr b="1" i="0" lang="en-US" sz="850" u="none" cap="none" strike="noStrike">
-                <a:solidFill>
-                  <a:srgbClr val="1E293B"/>
-                </a:solidFill>
-                <a:latin typeface="Noto Sans"/>
-                <a:ea typeface="Noto Sans"/>
-                <a:cs typeface="Noto Sans"/>
-                <a:sym typeface="Noto Sans"/>
-              </a:rPr>
-              <a:t>▶ 課程實戰 Codelabs：</a:t>
-            </a:r>
-            <a:r>
-              <a:rPr b="0" i="0" lang="en-US" sz="850" u="none" cap="none" strike="noStrike">
-                <a:solidFill>
-                  <a:srgbClr val="2563EB"/>
-                </a:solidFill>
-                <a:latin typeface="Noto Sans"/>
-                <a:ea typeface="Noto Sans"/>
-                <a:cs typeface="Noto Sans"/>
-                <a:sym typeface="Noto Sans"/>
-              </a:rPr>
-              <a:t>tedmax100.github.io/o11y_lab_for_dummies/k6-performance-testing/</a:t>
-            </a:r>
-            <a:endParaRPr/>
-          </a:p>
-        </p:txBody>
-      </p:sp>
       <p:sp>
         <p:nvSpPr>
           <p:cNvPr id="295" name="Codelabs_Link_Badge">

</xml_diff>

<commit_message>
chore(k6): re-export all slide decks via Google Slides with embedded fonts
All six decks were round-tripped through Google Slides, which embeds
Noto Sans / Noto Sans Mono and re-encodes some images. Slide counts,
native tables, connectors and charts are unchanged.

Co-Authored-By: Claude Opus 5.5 <noreply@anthropic.com>
</commit_message>
<xml_diff>
--- a/k6/slides/Ch6_k6_AI_Agent_Engineering.pptx
+++ b/k6/slides/Ch6_k6_AI_Agent_Engineering.pptx
@@ -16800,6 +16800,11 @@
               <a:spcAft>
                 <a:spcPts val="0"/>
               </a:spcAft>
+              <a:buClr>
+                <a:srgbClr val="000000"/>
+              </a:buClr>
+              <a:buSzPts val="850"/>
+              <a:buFont typeface="Arial"/>
               <a:buNone/>
             </a:pPr>
             <a:r>
@@ -16826,7 +16831,15 @@
               </a:rPr>
               <a:t>tedmax100.github.io/o11y_lab_for_dummies/k6-performance-testing/</a:t>
             </a:r>
-            <a:endParaRPr/>
+            <a:endParaRPr b="0" i="0" sz="1400" u="none" cap="none" strike="noStrike">
+              <a:solidFill>
+                <a:srgbClr val="000000"/>
+              </a:solidFill>
+              <a:latin typeface="Arial"/>
+              <a:ea typeface="Arial"/>
+              <a:cs typeface="Arial"/>
+              <a:sym typeface="Arial"/>
+            </a:endParaRPr>
           </a:p>
         </p:txBody>
       </p:sp>
@@ -17683,7 +17696,7 @@
                 <a:buNone/>
               </a:pPr>
               <a:r>
-                <a:rPr i="0" lang="en-US" sz="1700" u="none" cap="none" strike="noStrike">
+                <a:rPr b="0" i="0" lang="en-US" sz="1700" u="none" cap="none" strike="noStrike">
                   <a:solidFill>
                     <a:srgbClr val="1E293B"/>
                   </a:solidFill>
@@ -17694,7 +17707,7 @@
                 </a:rPr>
                 <a:t>自然語言意圖觸發</a:t>
               </a:r>
-              <a:endParaRPr i="0" sz="1700" u="none" cap="none" strike="noStrike">
+              <a:endParaRPr b="0" i="0" sz="1700" u="none" cap="none" strike="noStrike">
                 <a:solidFill>
                   <a:srgbClr val="1E293B"/>
                 </a:solidFill>
@@ -17723,7 +17736,7 @@
                 <a:buNone/>
               </a:pPr>
               <a:r>
-                <a:rPr i="0" lang="en-US" sz="1550" u="none" cap="none" strike="noStrike">
+                <a:rPr b="0" i="0" lang="en-US" sz="1550" u="none" cap="none" strike="noStrike">
                   <a:solidFill>
                     <a:srgbClr val="475569"/>
                   </a:solidFill>
@@ -17732,33 +17745,9 @@
                   <a:cs typeface="Noto Sans"/>
                   <a:sym typeface="Noto Sans"/>
                 </a:rPr>
-                <a:t>在 AI 視窗輸入 "write a smoke test" 或 "convert Playwright"，AI 助手即自動觸發對應技能，精準產出高質量</a:t>
+                <a:t>在 AI 視窗輸入 "write a smoke test" 或 "convert Playwright"，AI 助手即自動觸發對應技能，精準產出高質量程式碼。</a:t>
               </a:r>
-              <a:r>
-                <a:rPr lang="en-US" sz="1550">
-                  <a:solidFill>
-                    <a:srgbClr val="475569"/>
-                  </a:solidFill>
-                  <a:latin typeface="Noto Sans"/>
-                  <a:ea typeface="Noto Sans"/>
-                  <a:cs typeface="Noto Sans"/>
-                  <a:sym typeface="Noto Sans"/>
-                </a:rPr>
-                <a:t>程式</a:t>
-              </a:r>
-              <a:r>
-                <a:rPr i="0" lang="en-US" sz="1550" u="none" cap="none" strike="noStrike">
-                  <a:solidFill>
-                    <a:srgbClr val="475569"/>
-                  </a:solidFill>
-                  <a:latin typeface="Noto Sans"/>
-                  <a:ea typeface="Noto Sans"/>
-                  <a:cs typeface="Noto Sans"/>
-                  <a:sym typeface="Noto Sans"/>
-                </a:rPr>
-                <a:t>碼。</a:t>
-              </a:r>
-              <a:endParaRPr i="0" sz="1550" u="none" cap="none" strike="noStrike">
+              <a:endParaRPr b="0" i="0" sz="1550" u="none" cap="none" strike="noStrike">
                 <a:solidFill>
                   <a:srgbClr val="475569"/>
                 </a:solidFill>
@@ -19734,6 +19723,11 @@
               <a:spcAft>
                 <a:spcPts val="0"/>
               </a:spcAft>
+              <a:buClr>
+                <a:srgbClr val="000000"/>
+              </a:buClr>
+              <a:buSzPts val="850"/>
+              <a:buFont typeface="Arial"/>
               <a:buNone/>
             </a:pPr>
             <a:r>
@@ -19760,7 +19754,15 @@
               </a:rPr>
               <a:t>tedmax100.github.io/o11y_lab_for_dummies/k6-performance-testing/</a:t>
             </a:r>
-            <a:endParaRPr/>
+            <a:endParaRPr b="0" i="0" sz="1400" u="none" cap="none" strike="noStrike">
+              <a:solidFill>
+                <a:srgbClr val="000000"/>
+              </a:solidFill>
+              <a:latin typeface="Arial"/>
+              <a:ea typeface="Arial"/>
+              <a:cs typeface="Arial"/>
+              <a:sym typeface="Arial"/>
+            </a:endParaRPr>
           </a:p>
         </p:txBody>
       </p:sp>
@@ -20929,7 +20931,7 @@
         <p:spPr>
           <a:xfrm>
             <a:off x="7905750" y="1905000"/>
-            <a:ext cx="7429500" cy="4413900"/>
+            <a:ext cx="7429500" cy="4659300"/>
           </a:xfrm>
           <a:prstGeom prst="rect">
             <a:avLst/>
@@ -20967,7 +20969,7 @@
               <a:buNone/>
             </a:pPr>
             <a:r>
-              <a:rPr b="0" i="0" lang="en-US" sz="1500" u="none" cap="none" strike="noStrike">
+              <a:rPr b="0" i="0" lang="en-US" sz="1600" u="none" cap="none" strike="noStrike">
                 <a:solidFill>
                   <a:srgbClr val="64748B"/>
                 </a:solidFill>
@@ -20978,7 +20980,7 @@
               </a:rPr>
               <a:t># 1. 執行安全預覽 (零副作用確認磁碟變更)</a:t>
             </a:r>
-            <a:endParaRPr b="0" i="0" sz="1500" u="none" cap="none" strike="noStrike">
+            <a:endParaRPr b="0" i="0" sz="1600" u="none" cap="none" strike="noStrike">
               <a:solidFill>
                 <a:srgbClr val="64748B"/>
               </a:solidFill>
@@ -21007,7 +21009,7 @@
               <a:buNone/>
             </a:pPr>
             <a:r>
-              <a:rPr b="1" i="0" lang="en-US" sz="1500" u="none" cap="none" strike="noStrike">
+              <a:rPr b="1" i="0" lang="en-US" sz="1600" u="none" cap="none" strike="noStrike">
                 <a:solidFill>
                   <a:srgbClr val="38BDF8"/>
                 </a:solidFill>
@@ -21018,7 +21020,7 @@
               </a:rPr>
               <a:t>$ k6 x agent init cursor --dry-run</a:t>
             </a:r>
-            <a:endParaRPr b="1" i="0" sz="1500" u="none" cap="none" strike="noStrike">
+            <a:endParaRPr b="1" i="0" sz="1600" u="none" cap="none" strike="noStrike">
               <a:solidFill>
                 <a:srgbClr val="38BDF8"/>
               </a:solidFill>
@@ -21047,7 +21049,7 @@
               <a:buNone/>
             </a:pPr>
             <a:r>
-              <a:rPr b="0" i="0" lang="en-US" sz="1500" u="none" cap="none" strike="noStrike">
+              <a:rPr b="0" i="0" lang="en-US" sz="1600" u="none" cap="none" strike="noStrike">
                 <a:solidFill>
                   <a:srgbClr val="64748B"/>
                 </a:solidFill>
@@ -21058,7 +21060,7 @@
               </a:rPr>
               <a:t># 2. 檔案衝突判定決策流程 (Decision Tree)</a:t>
             </a:r>
-            <a:endParaRPr b="0" i="0" sz="1500" u="none" cap="none" strike="noStrike">
+            <a:endParaRPr b="0" i="0" sz="1600" u="none" cap="none" strike="noStrike">
               <a:solidFill>
                 <a:srgbClr val="64748B"/>
               </a:solidFill>
@@ -21087,7 +21089,7 @@
               <a:buNone/>
             </a:pPr>
             <a:r>
-              <a:rPr b="0" i="0" lang="en-US" sz="1500" u="none" cap="none" strike="noStrike">
+              <a:rPr b="0" i="0" lang="en-US" sz="1600" u="none" cap="none" strike="noStrike">
                 <a:solidFill>
                   <a:srgbClr val="F1F5F9"/>
                 </a:solidFill>
@@ -21098,7 +21100,7 @@
               </a:rPr>
               <a:t>掃描專案規則目錄 (.cursor/rules/*.mdc) ...</a:t>
             </a:r>
-            <a:endParaRPr b="0" i="0" sz="1500" u="none" cap="none" strike="noStrike">
+            <a:endParaRPr b="0" i="0" sz="1600" u="none" cap="none" strike="noStrike">
               <a:solidFill>
                 <a:srgbClr val="F1F5F9"/>
               </a:solidFill>
@@ -21127,7 +21129,7 @@
               <a:buNone/>
             </a:pPr>
             <a:r>
-              <a:rPr b="1" i="0" lang="en-US" sz="1500" u="none" cap="none" strike="noStrike">
+              <a:rPr b="1" i="0" lang="en-US" sz="1600" u="none" cap="none" strike="noStrike">
                 <a:solidFill>
                   <a:srgbClr val="4ADE80"/>
                 </a:solidFill>
@@ -21138,7 +21140,7 @@
               </a:rPr>
               <a:t>  ├── 檔案不存在 ──&gt; [寫入新檔] 並標記 Owner Tag 註解</a:t>
             </a:r>
-            <a:endParaRPr b="1" i="0" sz="1500" u="none" cap="none" strike="noStrike">
+            <a:endParaRPr b="1" i="0" sz="1600" u="none" cap="none" strike="noStrike">
               <a:solidFill>
                 <a:srgbClr val="4ADE80"/>
               </a:solidFill>
@@ -21167,7 +21169,7 @@
               <a:buNone/>
             </a:pPr>
             <a:r>
-              <a:rPr b="1" i="0" lang="en-US" sz="1500" u="none" cap="none" strike="noStrike">
+              <a:rPr b="1" i="0" lang="en-US" sz="1600" u="none" cap="none" strike="noStrike">
                 <a:solidFill>
                   <a:srgbClr val="FBBF24"/>
                 </a:solidFill>
@@ -21178,7 +21180,7 @@
               </a:rPr>
               <a:t>  └── 檔案已存在 ──&gt; 比對內容是否包含識別標籤：</a:t>
             </a:r>
-            <a:endParaRPr b="1" i="0" sz="1500" u="none" cap="none" strike="noStrike">
+            <a:endParaRPr b="1" i="0" sz="1600" u="none" cap="none" strike="noStrike">
               <a:solidFill>
                 <a:srgbClr val="FBBF24"/>
               </a:solidFill>
@@ -21207,7 +21209,7 @@
               <a:buNone/>
             </a:pPr>
             <a:r>
-              <a:rPr b="0" i="0" lang="en-US" sz="1500" u="none" cap="none" strike="noStrike">
+              <a:rPr b="0" i="0" lang="en-US" sz="1600" u="none" cap="none" strike="noStrike">
                 <a:solidFill>
                   <a:srgbClr val="F1F5F9"/>
                 </a:solidFill>
@@ -21218,7 +21220,7 @@
               </a:rPr>
               <a:t>        ├── 含標籤 (未修改) ──&gt; [安全同步更新] 升級至官方標準</a:t>
             </a:r>
-            <a:endParaRPr b="0" i="0" sz="1500" u="none" cap="none" strike="noStrike">
+            <a:endParaRPr b="0" i="0" sz="1600" u="none" cap="none" strike="noStrike">
               <a:solidFill>
                 <a:srgbClr val="F1F5F9"/>
               </a:solidFill>
@@ -21247,7 +21249,7 @@
               <a:buNone/>
             </a:pPr>
             <a:r>
-              <a:rPr b="1" i="0" lang="en-US" sz="1500" u="none" cap="none" strike="noStrike">
+              <a:rPr b="1" i="0" lang="en-US" sz="1600" u="none" cap="none" strike="noStrike">
                 <a:solidFill>
                   <a:srgbClr val="FBBF24"/>
                 </a:solidFill>
@@ -21258,7 +21260,7 @@
               </a:rPr>
               <a:t>        └── 不含標籤 (已修改) ──&gt; [智慧略過保護] 保留開發者客製！</a:t>
             </a:r>
-            <a:endParaRPr b="1" i="0" sz="1500" u="none" cap="none" strike="noStrike">
+            <a:endParaRPr b="1" i="0" sz="1600" u="none" cap="none" strike="noStrike">
               <a:solidFill>
                 <a:srgbClr val="FBBF24"/>
               </a:solidFill>
@@ -21287,7 +21289,7 @@
               <a:buNone/>
             </a:pPr>
             <a:r>
-              <a:rPr b="0" i="0" lang="en-US" sz="1500" u="none" cap="none" strike="noStrike">
+              <a:rPr b="0" i="0" lang="en-US" sz="1600" u="none" cap="none" strike="noStrike">
                 <a:solidFill>
                   <a:srgbClr val="64748B"/>
                 </a:solidFill>
@@ -21298,7 +21300,7 @@
               </a:rPr>
               <a:t># 3. 若確定要同步官方最新版，才使用 --force 強制覆蓋</a:t>
             </a:r>
-            <a:endParaRPr b="0" i="0" sz="1500" u="none" cap="none" strike="noStrike">
+            <a:endParaRPr b="0" i="0" sz="1600" u="none" cap="none" strike="noStrike">
               <a:solidFill>
                 <a:srgbClr val="64748B"/>
               </a:solidFill>
@@ -21327,7 +21329,7 @@
               <a:buNone/>
             </a:pPr>
             <a:r>
-              <a:rPr b="1" i="0" lang="en-US" sz="1500" u="none" cap="none" strike="noStrike">
+              <a:rPr b="1" i="0" lang="en-US" sz="1600" u="none" cap="none" strike="noStrike">
                 <a:solidFill>
                   <a:srgbClr val="38BDF8"/>
                 </a:solidFill>
@@ -21338,7 +21340,7 @@
               </a:rPr>
               <a:t>$ k6 x agent init cursor --force</a:t>
             </a:r>
-            <a:endParaRPr b="1" i="0" sz="1500" u="none" cap="none" strike="noStrike">
+            <a:endParaRPr b="1" i="0" sz="1600" u="none" cap="none" strike="noStrike">
               <a:solidFill>
                 <a:srgbClr val="38BDF8"/>
               </a:solidFill>
@@ -21367,7 +21369,7 @@
               <a:buNone/>
             </a:pPr>
             <a:r>
-              <a:rPr b="0" i="0" lang="en-US" sz="1500" u="none" cap="none" strike="noStrike">
+              <a:rPr b="0" i="0" lang="en-US" sz="1600" u="none" cap="none" strike="noStrike">
                 <a:solidFill>
                   <a:srgbClr val="64748B"/>
                 </a:solidFill>
@@ -21378,7 +21380,7 @@
               </a:rPr>
               <a:t># 4. 規則標籤範例 (.cursor/rules/k6-load-test.mdc)</a:t>
             </a:r>
-            <a:endParaRPr b="0" i="0" sz="1500" u="none" cap="none" strike="noStrike">
+            <a:endParaRPr b="0" i="0" sz="1600" u="none" cap="none" strike="noStrike">
               <a:solidFill>
                 <a:srgbClr val="64748B"/>
               </a:solidFill>
@@ -21407,7 +21409,7 @@
               <a:buNone/>
             </a:pPr>
             <a:r>
-              <a:rPr b="1" i="0" lang="en-US" sz="1500" u="none" cap="none" strike="noStrike">
+              <a:rPr b="1" i="0" lang="en-US" sz="1600" u="none" cap="none" strike="noStrike">
                 <a:solidFill>
                   <a:srgbClr val="4ADE80"/>
                 </a:solidFill>
@@ -21418,7 +21420,7 @@
               </a:rPr>
               <a:t>&lt;!-- generated by k6 x agent - DO NOT EDIT THIS BLOCK --&gt;</a:t>
             </a:r>
-            <a:endParaRPr b="1" i="0" sz="1500" u="none" cap="none" strike="noStrike">
+            <a:endParaRPr b="1" i="0" sz="1600" u="none" cap="none" strike="noStrike">
               <a:solidFill>
                 <a:srgbClr val="4ADE80"/>
               </a:solidFill>
@@ -21447,7 +21449,7 @@
               <a:buNone/>
             </a:pPr>
             <a:r>
-              <a:rPr b="0" i="0" lang="en-US" sz="1500" u="none" cap="none" strike="noStrike">
+              <a:rPr b="0" i="0" lang="en-US" sz="1600" u="none" cap="none" strike="noStrike">
                 <a:solidFill>
                   <a:srgbClr val="F1F5F9"/>
                 </a:solidFill>
@@ -21458,7 +21460,7 @@
               </a:rPr>
               <a:t>description: "Execute standard production-grade load tests with k6"</a:t>
             </a:r>
-            <a:endParaRPr b="0" i="0" sz="1500" u="none" cap="none" strike="noStrike">
+            <a:endParaRPr b="0" i="0" sz="1600" u="none" cap="none" strike="noStrike">
               <a:solidFill>
                 <a:srgbClr val="F1F5F9"/>
               </a:solidFill>
@@ -21487,7 +21489,7 @@
               <a:buNone/>
             </a:pPr>
             <a:r>
-              <a:rPr b="0" i="0" lang="en-US" sz="1500" u="none" cap="none" strike="noStrike">
+              <a:rPr b="0" i="0" lang="en-US" sz="1600" u="none" cap="none" strike="noStrike">
                 <a:solidFill>
                   <a:srgbClr val="F1F5F9"/>
                 </a:solidFill>
@@ -21498,7 +21500,7 @@
               </a:rPr>
               <a:t>globs: ["**/*.js", "**/*.ts"]</a:t>
             </a:r>
-            <a:endParaRPr b="0" i="0" sz="1500" u="none" cap="none" strike="noStrike">
+            <a:endParaRPr b="0" i="0" sz="1600" u="none" cap="none" strike="noStrike">
               <a:solidFill>
                 <a:srgbClr val="F1F5F9"/>
               </a:solidFill>
@@ -21787,6 +21789,11 @@
               <a:spcAft>
                 <a:spcPts val="0"/>
               </a:spcAft>
+              <a:buClr>
+                <a:srgbClr val="000000"/>
+              </a:buClr>
+              <a:buSzPts val="850"/>
+              <a:buFont typeface="Arial"/>
               <a:buNone/>
             </a:pPr>
             <a:r>
@@ -21813,7 +21820,15 @@
               </a:rPr>
               <a:t>tedmax100.github.io/o11y_lab_for_dummies/k6-performance-testing/</a:t>
             </a:r>
-            <a:endParaRPr/>
+            <a:endParaRPr b="0" i="0" sz="1400" u="none" cap="none" strike="noStrike">
+              <a:solidFill>
+                <a:srgbClr val="000000"/>
+              </a:solidFill>
+              <a:latin typeface="Arial"/>
+              <a:ea typeface="Arial"/>
+              <a:cs typeface="Arial"/>
+              <a:sym typeface="Arial"/>
+            </a:endParaRPr>
           </a:p>
         </p:txBody>
       </p:sp>
@@ -22249,7 +22264,7 @@
         <p:spPr>
           <a:xfrm>
             <a:off x="852081" y="1828800"/>
-            <a:ext cx="6381900" cy="4169100"/>
+            <a:ext cx="6381900" cy="4396800"/>
           </a:xfrm>
           <a:prstGeom prst="rect">
             <a:avLst/>
@@ -22287,7 +22302,7 @@
               <a:buNone/>
             </a:pPr>
             <a:r>
-              <a:rPr b="0" i="0" lang="en-US" sz="1450" u="none" cap="none" strike="noStrike">
+              <a:rPr b="0" i="0" lang="en-US" sz="1550" u="none" cap="none" strike="noStrike">
                 <a:solidFill>
                   <a:srgbClr val="64748B"/>
                 </a:solidFill>
@@ -22298,7 +22313,7 @@
               </a:rPr>
               <a:t># 1. 為指定編輯器進行初始化 (例如 Cursor 或 Claude Code)</a:t>
             </a:r>
-            <a:endParaRPr b="0" i="0" sz="1450" u="none" cap="none" strike="noStrike">
+            <a:endParaRPr b="0" i="0" sz="1550" u="none" cap="none" strike="noStrike">
               <a:solidFill>
                 <a:srgbClr val="64748B"/>
               </a:solidFill>
@@ -22327,7 +22342,7 @@
               <a:buNone/>
             </a:pPr>
             <a:r>
-              <a:rPr b="1" i="0" lang="en-US" sz="1450" u="none" cap="none" strike="noStrike">
+              <a:rPr b="1" i="0" lang="en-US" sz="1550" u="none" cap="none" strike="noStrike">
                 <a:solidFill>
                   <a:srgbClr val="38BDF8"/>
                 </a:solidFill>
@@ -22338,7 +22353,7 @@
               </a:rPr>
               <a:t>$ k6 x agent init cursor</a:t>
             </a:r>
-            <a:endParaRPr b="0" i="0" sz="1450" u="none" cap="none" strike="noStrike">
+            <a:endParaRPr b="0" i="0" sz="1550" u="none" cap="none" strike="noStrike">
               <a:solidFill>
                 <a:srgbClr val="94A3B8"/>
               </a:solidFill>
@@ -22367,7 +22382,7 @@
               <a:buNone/>
             </a:pPr>
             <a:r>
-              <a:rPr b="1" i="0" lang="en-US" sz="1450" u="none" cap="none" strike="noStrike">
+              <a:rPr b="1" i="0" lang="en-US" sz="1550" u="none" cap="none" strike="noStrike">
                 <a:solidFill>
                   <a:srgbClr val="38BDF8"/>
                 </a:solidFill>
@@ -22378,7 +22393,7 @@
               </a:rPr>
               <a:t>$ k6 x agent init claude-code</a:t>
             </a:r>
-            <a:endParaRPr b="0" i="0" sz="1450" u="none" cap="none" strike="noStrike">
+            <a:endParaRPr b="0" i="0" sz="1550" u="none" cap="none" strike="noStrike">
               <a:solidFill>
                 <a:srgbClr val="94A3B8"/>
               </a:solidFill>
@@ -22407,7 +22422,7 @@
               <a:buNone/>
             </a:pPr>
             <a:r>
-              <a:rPr b="0" i="0" lang="en-US" sz="1450" u="none" cap="none" strike="noStrike">
+              <a:rPr b="0" i="0" lang="en-US" sz="1550" u="none" cap="none" strike="noStrike">
                 <a:solidFill>
                   <a:srgbClr val="64748B"/>
                 </a:solidFill>
@@ -22418,7 +22433,7 @@
               </a:rPr>
               <a:t># 2. 一鍵初始化所有支援的編輯器 (團隊協作最佳實踐)</a:t>
             </a:r>
-            <a:endParaRPr b="0" i="0" sz="1450" u="none" cap="none" strike="noStrike">
+            <a:endParaRPr b="0" i="0" sz="1550" u="none" cap="none" strike="noStrike">
               <a:solidFill>
                 <a:srgbClr val="64748B"/>
               </a:solidFill>
@@ -22447,7 +22462,7 @@
               <a:buNone/>
             </a:pPr>
             <a:r>
-              <a:rPr b="1" i="0" lang="en-US" sz="1450" u="none" cap="none" strike="noStrike">
+              <a:rPr b="1" i="0" lang="en-US" sz="1550" u="none" cap="none" strike="noStrike">
                 <a:solidFill>
                   <a:srgbClr val="38BDF8"/>
                 </a:solidFill>
@@ -22458,7 +22473,7 @@
               </a:rPr>
               <a:t>$ k6 x agent init --all</a:t>
             </a:r>
-            <a:endParaRPr b="0" i="0" sz="1450" u="none" cap="none" strike="noStrike">
+            <a:endParaRPr b="0" i="0" sz="1550" u="none" cap="none" strike="noStrike">
               <a:solidFill>
                 <a:srgbClr val="94A3B8"/>
               </a:solidFill>
@@ -22487,7 +22502,7 @@
               <a:buNone/>
             </a:pPr>
             <a:r>
-              <a:rPr b="0" i="0" lang="en-US" sz="1450" u="none" cap="none" strike="noStrike">
+              <a:rPr b="0" i="0" lang="en-US" sz="1550" u="none" cap="none" strike="noStrike">
                 <a:solidFill>
                   <a:srgbClr val="64748B"/>
                 </a:solidFill>
@@ -22498,7 +22513,7 @@
               </a:rPr>
               <a:t># 3. 預覽將產生的檔案與路徑 (安全檢查，不寫入磁碟)</a:t>
             </a:r>
-            <a:endParaRPr b="0" i="0" sz="1450" u="none" cap="none" strike="noStrike">
+            <a:endParaRPr b="0" i="0" sz="1550" u="none" cap="none" strike="noStrike">
               <a:solidFill>
                 <a:srgbClr val="64748B"/>
               </a:solidFill>
@@ -22527,7 +22542,7 @@
               <a:buNone/>
             </a:pPr>
             <a:r>
-              <a:rPr b="1" i="0" lang="en-US" sz="1450" u="none" cap="none" strike="noStrike">
+              <a:rPr b="1" i="0" lang="en-US" sz="1550" u="none" cap="none" strike="noStrike">
                 <a:solidFill>
                   <a:srgbClr val="38BDF8"/>
                 </a:solidFill>
@@ -22538,7 +22553,7 @@
               </a:rPr>
               <a:t>$ k6 x agent init --dry-run cursor</a:t>
             </a:r>
-            <a:endParaRPr b="0" i="0" sz="1450" u="none" cap="none" strike="noStrike">
+            <a:endParaRPr b="0" i="0" sz="1550" u="none" cap="none" strike="noStrike">
               <a:solidFill>
                 <a:srgbClr val="94A3B8"/>
               </a:solidFill>
@@ -22567,7 +22582,7 @@
               <a:buNone/>
             </a:pPr>
             <a:r>
-              <a:rPr b="0" i="0" lang="en-US" sz="1450" u="none" cap="none" strike="noStrike">
+              <a:rPr b="0" i="0" lang="en-US" sz="1550" u="none" cap="none" strike="noStrike">
                 <a:solidFill>
                   <a:srgbClr val="64748B"/>
                 </a:solidFill>
@@ -22578,7 +22593,7 @@
               </a:rPr>
               <a:t># 4. 強制覆蓋重置所有技能與 MCP 設定 (版本升級專用)</a:t>
             </a:r>
-            <a:endParaRPr b="0" i="0" sz="1450" u="none" cap="none" strike="noStrike">
+            <a:endParaRPr b="0" i="0" sz="1550" u="none" cap="none" strike="noStrike">
               <a:solidFill>
                 <a:srgbClr val="64748B"/>
               </a:solidFill>
@@ -22607,7 +22622,7 @@
               <a:buNone/>
             </a:pPr>
             <a:r>
-              <a:rPr b="1" i="0" lang="en-US" sz="1450" u="none" cap="none" strike="noStrike">
+              <a:rPr b="1" i="0" lang="en-US" sz="1550" u="none" cap="none" strike="noStrike">
                 <a:solidFill>
                   <a:srgbClr val="38BDF8"/>
                 </a:solidFill>
@@ -22618,7 +22633,7 @@
               </a:rPr>
               <a:t>$ k6 x agent init --force cursor</a:t>
             </a:r>
-            <a:endParaRPr b="0" i="0" sz="1450" u="none" cap="none" strike="noStrike">
+            <a:endParaRPr b="0" i="0" sz="1550" u="none" cap="none" strike="noStrike">
               <a:solidFill>
                 <a:srgbClr val="94A3B8"/>
               </a:solidFill>
@@ -22647,7 +22662,7 @@
               <a:buNone/>
             </a:pPr>
             <a:r>
-              <a:rPr b="0" i="0" lang="en-US" sz="1450" u="none" cap="none" strike="noStrike">
+              <a:rPr b="0" i="0" lang="en-US" sz="1550" u="none" cap="none" strike="noStrike">
                 <a:solidFill>
                   <a:srgbClr val="64748B"/>
                 </a:solidFill>
@@ -22658,7 +22673,7 @@
               </a:rPr>
               <a:t># 5. 檢查當前專案的 AI 技能與 MCP 伺服器連線狀態</a:t>
             </a:r>
-            <a:endParaRPr b="0" i="0" sz="1450" u="none" cap="none" strike="noStrike">
+            <a:endParaRPr b="0" i="0" sz="1550" u="none" cap="none" strike="noStrike">
               <a:solidFill>
                 <a:srgbClr val="64748B"/>
               </a:solidFill>
@@ -22687,7 +22702,7 @@
               <a:buNone/>
             </a:pPr>
             <a:r>
-              <a:rPr b="1" i="0" lang="en-US" sz="1450" u="none" cap="none" strike="noStrike">
+              <a:rPr b="1" i="0" lang="en-US" sz="1550" u="none" cap="none" strike="noStrike">
                 <a:solidFill>
                   <a:srgbClr val="38BDF8"/>
                 </a:solidFill>
@@ -22698,7 +22713,7 @@
               </a:rPr>
               <a:t>$ k6 x agent status</a:t>
             </a:r>
-            <a:endParaRPr b="0" i="0" sz="1450" u="none" cap="none" strike="noStrike">
+            <a:endParaRPr b="0" i="0" sz="1550" u="none" cap="none" strike="noStrike">
               <a:solidFill>
                 <a:srgbClr val="94A3B8"/>
               </a:solidFill>
@@ -22727,7 +22742,7 @@
               <a:buNone/>
             </a:pPr>
             <a:r>
-              <a:rPr b="0" i="0" lang="en-US" sz="1450" u="none" cap="none" strike="noStrike">
+              <a:rPr b="0" i="0" lang="en-US" sz="1550" u="none" cap="none" strike="noStrike">
                 <a:solidFill>
                   <a:srgbClr val="64748B"/>
                 </a:solidFill>
@@ -22738,7 +22753,7 @@
               </a:rPr>
               <a:t># 6. 查看內建的所有 AI 技能清單與詳細描述</a:t>
             </a:r>
-            <a:endParaRPr b="0" i="0" sz="1450" u="none" cap="none" strike="noStrike">
+            <a:endParaRPr b="0" i="0" sz="1550" u="none" cap="none" strike="noStrike">
               <a:solidFill>
                 <a:srgbClr val="64748B"/>
               </a:solidFill>
@@ -22767,7 +22782,7 @@
               <a:buNone/>
             </a:pPr>
             <a:r>
-              <a:rPr b="1" i="0" lang="en-US" sz="1450" u="none" cap="none" strike="noStrike">
+              <a:rPr b="1" i="0" lang="en-US" sz="1550" u="none" cap="none" strike="noStrike">
                 <a:solidFill>
                   <a:srgbClr val="38BDF8"/>
                 </a:solidFill>
@@ -22778,7 +22793,7 @@
               </a:rPr>
               <a:t>$ k6 x agent skills list</a:t>
             </a:r>
-            <a:endParaRPr b="0" i="0" sz="1450" u="none" cap="none" strike="noStrike">
+            <a:endParaRPr b="0" i="0" sz="1550" u="none" cap="none" strike="noStrike">
               <a:solidFill>
                 <a:srgbClr val="94A3B8"/>
               </a:solidFill>
@@ -24609,6 +24624,11 @@
               <a:spcAft>
                 <a:spcPts val="0"/>
               </a:spcAft>
+              <a:buClr>
+                <a:srgbClr val="000000"/>
+              </a:buClr>
+              <a:buSzPts val="850"/>
+              <a:buFont typeface="Arial"/>
               <a:buNone/>
             </a:pPr>
             <a:r>
@@ -24635,7 +24655,15 @@
               </a:rPr>
               <a:t>tedmax100.github.io/o11y_lab_for_dummies/k6-performance-testing/</a:t>
             </a:r>
-            <a:endParaRPr/>
+            <a:endParaRPr b="0" i="0" sz="1400" u="none" cap="none" strike="noStrike">
+              <a:solidFill>
+                <a:srgbClr val="000000"/>
+              </a:solidFill>
+              <a:latin typeface="Arial"/>
+              <a:ea typeface="Arial"/>
+              <a:cs typeface="Arial"/>
+              <a:sym typeface="Arial"/>
+            </a:endParaRPr>
           </a:p>
         </p:txBody>
       </p:sp>
@@ -26575,6 +26603,11 @@
               <a:spcAft>
                 <a:spcPts val="0"/>
               </a:spcAft>
+              <a:buClr>
+                <a:srgbClr val="000000"/>
+              </a:buClr>
+              <a:buSzPts val="850"/>
+              <a:buFont typeface="Arial"/>
               <a:buNone/>
             </a:pPr>
             <a:r>
@@ -26601,7 +26634,15 @@
               </a:rPr>
               <a:t>tedmax100.github.io/o11y_lab_for_dummies/k6-performance-testing/</a:t>
             </a:r>
-            <a:endParaRPr/>
+            <a:endParaRPr b="0" i="0" sz="1400" u="none" cap="none" strike="noStrike">
+              <a:solidFill>
+                <a:srgbClr val="000000"/>
+              </a:solidFill>
+              <a:latin typeface="Arial"/>
+              <a:ea typeface="Arial"/>
+              <a:cs typeface="Arial"/>
+              <a:sym typeface="Arial"/>
+            </a:endParaRPr>
           </a:p>
         </p:txBody>
       </p:sp>
@@ -28839,6 +28880,11 @@
               <a:spcAft>
                 <a:spcPts val="0"/>
               </a:spcAft>
+              <a:buClr>
+                <a:srgbClr val="000000"/>
+              </a:buClr>
+              <a:buSzPts val="850"/>
+              <a:buFont typeface="Arial"/>
               <a:buNone/>
             </a:pPr>
             <a:r>
@@ -28865,7 +28911,15 @@
               </a:rPr>
               <a:t>tedmax100.github.io/o11y_lab_for_dummies/k6-performance-testing/</a:t>
             </a:r>
-            <a:endParaRPr/>
+            <a:endParaRPr b="0" i="0" sz="1400" u="none" cap="none" strike="noStrike">
+              <a:solidFill>
+                <a:srgbClr val="000000"/>
+              </a:solidFill>
+              <a:latin typeface="Arial"/>
+              <a:ea typeface="Arial"/>
+              <a:cs typeface="Arial"/>
+              <a:sym typeface="Arial"/>
+            </a:endParaRPr>
           </a:p>
         </p:txBody>
       </p:sp>
@@ -29604,7 +29658,7 @@
                 <a:p>
                   <a:pPr indent="0" lvl="0" marL="0" marR="0" rtl="0" algn="l">
                     <a:lnSpc>
-                      <a:spcPct val="100000"/>
+                      <a:spcPct val="115000"/>
                     </a:lnSpc>
                     <a:spcBef>
                       <a:spcPts val="0"/>
@@ -29620,7 +29674,7 @@
                     <a:buNone/>
                   </a:pPr>
                   <a:r>
-                    <a:rPr b="0" i="0" lang="en-US" sz="1450" u="none" cap="none" strike="noStrike">
+                    <a:rPr b="0" i="0" lang="en-US" sz="1550" u="none" cap="none" strike="noStrike">
                       <a:solidFill>
                         <a:srgbClr val="64748B"/>
                       </a:solidFill>
@@ -29632,7 +29686,7 @@
                     <a:t>● ● ●  </a:t>
                   </a:r>
                   <a:r>
-                    <a:rPr b="0" i="0" lang="en-US" sz="1450" u="none" cap="none" strike="noStrike">
+                    <a:rPr b="0" i="0" lang="en-US" sz="1550" u="none" cap="none" strike="noStrike">
                       <a:solidFill>
                         <a:srgbClr val="94A3B8"/>
                       </a:solidFill>
@@ -29643,7 +29697,7 @@
                     </a:rPr>
                     <a:t>實戰指令</a:t>
                   </a:r>
-                  <a:endParaRPr b="0" i="0" sz="1450" u="none" cap="none" strike="noStrike">
+                  <a:endParaRPr b="0" i="0" sz="1550" u="none" cap="none" strike="noStrike">
                     <a:solidFill>
                       <a:srgbClr val="64748B"/>
                     </a:solidFill>
@@ -29656,7 +29710,7 @@
                 <a:p>
                   <a:pPr indent="0" lvl="0" marL="0" marR="0" rtl="0" algn="l">
                     <a:lnSpc>
-                      <a:spcPct val="100000"/>
+                      <a:spcPct val="115000"/>
                     </a:lnSpc>
                     <a:spcBef>
                       <a:spcPts val="900"/>
@@ -29672,7 +29726,7 @@
                     <a:buNone/>
                   </a:pPr>
                   <a:r>
-                    <a:rPr b="1" i="0" lang="en-US" sz="1450" u="none" cap="none" strike="noStrike">
+                    <a:rPr b="1" i="0" lang="en-US" sz="1550" u="none" cap="none" strike="noStrike">
                       <a:solidFill>
                         <a:srgbClr val="38BDF8"/>
                       </a:solidFill>
@@ -29683,7 +29737,7 @@
                     </a:rPr>
                     <a:t>$ k6 x agent init cursor</a:t>
                   </a:r>
-                  <a:endParaRPr b="1" i="0" sz="1450" u="none" cap="none" strike="noStrike">
+                  <a:endParaRPr b="1" i="0" sz="1550" u="none" cap="none" strike="noStrike">
                     <a:solidFill>
                       <a:srgbClr val="38BDF8"/>
                     </a:solidFill>
@@ -29696,7 +29750,7 @@
                 <a:p>
                   <a:pPr indent="0" lvl="0" marL="0" marR="0" rtl="0" algn="l">
                     <a:lnSpc>
-                      <a:spcPct val="100000"/>
+                      <a:spcPct val="115000"/>
                     </a:lnSpc>
                     <a:spcBef>
                       <a:spcPts val="300"/>
@@ -29712,7 +29766,7 @@
                     <a:buNone/>
                   </a:pPr>
                   <a:r>
-                    <a:rPr b="0" i="0" lang="en-US" u="none" cap="none" strike="noStrike">
+                    <a:rPr b="0" i="0" lang="en-US" sz="1500" u="none" cap="none" strike="noStrike">
                       <a:solidFill>
                         <a:srgbClr val="64748B"/>
                       </a:solidFill>
@@ -29723,7 +29777,7 @@
                     </a:rPr>
                     <a:t># 初始化 Cursor (或改用 claude-code)</a:t>
                   </a:r>
-                  <a:endParaRPr b="0" i="0" u="none" cap="none" strike="noStrike">
+                  <a:endParaRPr b="0" i="0" sz="1500" u="none" cap="none" strike="noStrike">
                     <a:solidFill>
                       <a:srgbClr val="64748B"/>
                     </a:solidFill>
@@ -29736,7 +29790,7 @@
                 <a:p>
                   <a:pPr indent="0" lvl="0" marL="0" marR="0" rtl="0" algn="l">
                     <a:lnSpc>
-                      <a:spcPct val="100000"/>
+                      <a:spcPct val="115000"/>
                     </a:lnSpc>
                     <a:spcBef>
                       <a:spcPts val="1050"/>
@@ -29752,7 +29806,7 @@
                     <a:buNone/>
                   </a:pPr>
                   <a:r>
-                    <a:rPr b="1" i="0" lang="en-US" sz="1450" u="none" cap="none" strike="noStrike">
+                    <a:rPr b="1" i="0" lang="en-US" sz="1550" u="none" cap="none" strike="noStrike">
                       <a:solidFill>
                         <a:srgbClr val="38BDF8"/>
                       </a:solidFill>
@@ -29763,7 +29817,7 @@
                     </a:rPr>
                     <a:t>$ k6 x agent status</a:t>
                   </a:r>
-                  <a:endParaRPr b="1" i="0" sz="1450" u="none" cap="none" strike="noStrike">
+                  <a:endParaRPr b="1" i="0" sz="1550" u="none" cap="none" strike="noStrike">
                     <a:solidFill>
                       <a:srgbClr val="38BDF8"/>
                     </a:solidFill>
@@ -29776,7 +29830,7 @@
                 <a:p>
                   <a:pPr indent="0" lvl="0" marL="0" marR="0" rtl="0" algn="l">
                     <a:lnSpc>
-                      <a:spcPct val="100000"/>
+                      <a:spcPct val="115000"/>
                     </a:lnSpc>
                     <a:spcBef>
                       <a:spcPts val="300"/>
@@ -29792,7 +29846,7 @@
                     <a:buNone/>
                   </a:pPr>
                   <a:r>
-                    <a:rPr b="0" i="0" lang="en-US" u="none" cap="none" strike="noStrike">
+                    <a:rPr b="0" i="0" lang="en-US" sz="1500" u="none" cap="none" strike="noStrike">
                       <a:solidFill>
                         <a:srgbClr val="64748B"/>
                       </a:solidFill>
@@ -29803,7 +29857,7 @@
                     </a:rPr>
                     <a:t># 檢查 MCP 伺服器連線狀態與 11 個技能清單</a:t>
                   </a:r>
-                  <a:endParaRPr b="0" i="0" u="none" cap="none" strike="noStrike">
+                  <a:endParaRPr b="0" i="0" sz="1500" u="none" cap="none" strike="noStrike">
                     <a:solidFill>
                       <a:srgbClr val="64748B"/>
                     </a:solidFill>
@@ -30503,7 +30557,7 @@
                 <a:p>
                   <a:pPr indent="0" lvl="0" marL="0" marR="0" rtl="0" algn="l">
                     <a:lnSpc>
-                      <a:spcPct val="100000"/>
+                      <a:spcPct val="115000"/>
                     </a:lnSpc>
                     <a:spcBef>
                       <a:spcPts val="0"/>
@@ -30519,7 +30573,7 @@
                     <a:buNone/>
                   </a:pPr>
                   <a:r>
-                    <a:rPr b="0" i="0" lang="en-US" sz="1450" u="none" cap="none" strike="noStrike">
+                    <a:rPr b="0" i="0" lang="en-US" sz="1550" u="none" cap="none" strike="noStrike">
                       <a:solidFill>
                         <a:srgbClr val="64748B"/>
                       </a:solidFill>
@@ -30531,7 +30585,7 @@
                     <a:t>● ● ●  </a:t>
                   </a:r>
                   <a:r>
-                    <a:rPr b="0" i="0" lang="en-US" sz="1450" u="none" cap="none" strike="noStrike">
+                    <a:rPr b="0" i="0" lang="en-US" sz="1550" u="none" cap="none" strike="noStrike">
                       <a:solidFill>
                         <a:srgbClr val="94A3B8"/>
                       </a:solidFill>
@@ -30542,7 +30596,7 @@
                     </a:rPr>
                     <a:t>Prompt 指引</a:t>
                   </a:r>
-                  <a:endParaRPr b="0" i="0" sz="1450" u="none" cap="none" strike="noStrike">
+                  <a:endParaRPr b="0" i="0" sz="1550" u="none" cap="none" strike="noStrike">
                     <a:solidFill>
                       <a:srgbClr val="64748B"/>
                     </a:solidFill>
@@ -30555,7 +30609,7 @@
                 <a:p>
                   <a:pPr indent="0" lvl="0" marL="0" marR="0" rtl="0" algn="l">
                     <a:lnSpc>
-                      <a:spcPct val="100000"/>
+                      <a:spcPct val="115000"/>
                     </a:lnSpc>
                     <a:spcBef>
                       <a:spcPts val="900"/>
@@ -30571,7 +30625,7 @@
                     <a:buNone/>
                   </a:pPr>
                   <a:r>
-                    <a:rPr b="0" i="0" lang="en-US" sz="1450" u="none" cap="none" strike="noStrike">
+                    <a:rPr b="0" i="0" lang="en-US" sz="1550" u="none" cap="none" strike="noStrike">
                       <a:solidFill>
                         <a:srgbClr val="F1F5F9"/>
                       </a:solidFill>
@@ -30582,7 +30636,7 @@
                     </a:rPr>
                     <a:t>Prompt: "針對 QuickPizza 的 /api/pizza 端點撰寫 1 VU 冒煙測試腳本，包含 check 軟斷言與</a:t>
                   </a:r>
-                  <a:endParaRPr b="0" i="0" sz="1450" u="none" cap="none" strike="noStrike">
+                  <a:endParaRPr b="0" i="0" sz="1550" u="none" cap="none" strike="noStrike">
                     <a:solidFill>
                       <a:srgbClr val="F1F5F9"/>
                     </a:solidFill>
@@ -30595,7 +30649,7 @@
                 <a:p>
                   <a:pPr indent="0" lvl="0" marL="0" marR="0" rtl="0" algn="l">
                     <a:lnSpc>
-                      <a:spcPct val="100000"/>
+                      <a:spcPct val="115000"/>
                     </a:lnSpc>
                     <a:spcBef>
                       <a:spcPts val="450"/>
@@ -30611,7 +30665,7 @@
                     <a:buNone/>
                   </a:pPr>
                   <a:r>
-                    <a:rPr b="1" i="0" lang="en-US" sz="1450" u="none" cap="none" strike="noStrike">
+                    <a:rPr b="1" i="0" lang="en-US" sz="1550" u="none" cap="none" strike="noStrike">
                       <a:solidFill>
                         <a:srgbClr val="FBBF24"/>
                       </a:solidFill>
@@ -30622,7 +30676,7 @@
                     </a:rPr>
                     <a:t>http.url 標籤，並請使用 validate_script 工具預檢腳本合法性。"</a:t>
                   </a:r>
-                  <a:endParaRPr b="1" i="0" sz="1450" u="none" cap="none" strike="noStrike">
+                  <a:endParaRPr b="1" i="0" sz="1550" u="none" cap="none" strike="noStrike">
                     <a:solidFill>
                       <a:srgbClr val="FBBF24"/>
                     </a:solidFill>
@@ -31322,7 +31376,7 @@
                 <a:p>
                   <a:pPr indent="0" lvl="0" marL="0" marR="0" rtl="0" algn="l">
                     <a:lnSpc>
-                      <a:spcPct val="100000"/>
+                      <a:spcPct val="115000"/>
                     </a:lnSpc>
                     <a:spcBef>
                       <a:spcPts val="0"/>
@@ -31338,7 +31392,7 @@
                     <a:buNone/>
                   </a:pPr>
                   <a:r>
-                    <a:rPr b="0" i="0" lang="en-US" sz="1450" u="none" cap="none" strike="noStrike">
+                    <a:rPr b="0" i="0" lang="en-US" sz="1550" u="none" cap="none" strike="noStrike">
                       <a:solidFill>
                         <a:srgbClr val="64748B"/>
                       </a:solidFill>
@@ -31350,7 +31404,7 @@
                     <a:t>● ● ●  </a:t>
                   </a:r>
                   <a:r>
-                    <a:rPr b="0" i="0" lang="en-US" sz="1450" u="none" cap="none" strike="noStrike">
+                    <a:rPr b="0" i="0" lang="en-US" sz="1550" u="none" cap="none" strike="noStrike">
                       <a:solidFill>
                         <a:srgbClr val="94A3B8"/>
                       </a:solidFill>
@@ -31361,7 +31415,7 @@
                     </a:rPr>
                     <a:t>Prompt 指引</a:t>
                   </a:r>
-                  <a:endParaRPr b="0" i="0" sz="1450" u="none" cap="none" strike="noStrike">
+                  <a:endParaRPr b="0" i="0" sz="1550" u="none" cap="none" strike="noStrike">
                     <a:solidFill>
                       <a:srgbClr val="64748B"/>
                     </a:solidFill>
@@ -31374,7 +31428,7 @@
                 <a:p>
                   <a:pPr indent="0" lvl="0" marL="0" marR="0" rtl="0" algn="l">
                     <a:lnSpc>
-                      <a:spcPct val="100000"/>
+                      <a:spcPct val="115000"/>
                     </a:lnSpc>
                     <a:spcBef>
                       <a:spcPts val="900"/>
@@ -31390,7 +31444,7 @@
                     <a:buNone/>
                   </a:pPr>
                   <a:r>
-                    <a:rPr b="0" i="0" lang="en-US" sz="1450" u="none" cap="none" strike="noStrike">
+                    <a:rPr b="0" i="0" lang="en-US" sz="1550" u="none" cap="none" strike="noStrike">
                       <a:solidFill>
                         <a:srgbClr val="F1F5F9"/>
                       </a:solidFill>
@@ -31401,7 +31455,7 @@
                     </a:rPr>
                     <a:t>Prompt: "請將這段 Playwright 登入測試轉譯為 k6 browser 腳本，加入 finally page.close()</a:t>
                   </a:r>
-                  <a:endParaRPr b="0" i="0" sz="1450" u="none" cap="none" strike="noStrike">
+                  <a:endParaRPr b="0" i="0" sz="1550" u="none" cap="none" strike="noStrike">
                     <a:solidFill>
                       <a:srgbClr val="F1F5F9"/>
                     </a:solidFill>
@@ -31414,7 +31468,7 @@
                 <a:p>
                   <a:pPr indent="0" lvl="0" marL="0" marR="0" rtl="0" algn="l">
                     <a:lnSpc>
-                      <a:spcPct val="100000"/>
+                      <a:spcPct val="115000"/>
                     </a:lnSpc>
                     <a:spcBef>
                       <a:spcPts val="450"/>
@@ -31430,7 +31484,7 @@
                     <a:buNone/>
                   </a:pPr>
                   <a:r>
-                    <a:rPr b="1" i="0" lang="en-US" sz="1450" u="none" cap="none" strike="noStrike">
+                    <a:rPr b="1" i="0" lang="en-US" sz="1550" u="none" cap="none" strike="noStrike">
                       <a:solidFill>
                         <a:srgbClr val="FBBF24"/>
                       </a:solidFill>
@@ -31441,7 +31495,7 @@
                     </a:rPr>
                     <a:t>軍規保護，並設定 99:1 混合流量模型。"</a:t>
                   </a:r>
-                  <a:endParaRPr b="1" i="0" sz="1450" u="none" cap="none" strike="noStrike">
+                  <a:endParaRPr b="1" i="0" sz="1550" u="none" cap="none" strike="noStrike">
                     <a:solidFill>
                       <a:srgbClr val="FBBF24"/>
                     </a:solidFill>
@@ -31917,6 +31971,11 @@
               <a:spcAft>
                 <a:spcPts val="0"/>
               </a:spcAft>
+              <a:buClr>
+                <a:srgbClr val="000000"/>
+              </a:buClr>
+              <a:buSzPts val="850"/>
+              <a:buFont typeface="Arial"/>
               <a:buNone/>
             </a:pPr>
             <a:r>
@@ -31943,7 +32002,15 @@
               </a:rPr>
               <a:t>tedmax100.github.io/o11y_lab_for_dummies/k6-performance-testing/</a:t>
             </a:r>
-            <a:endParaRPr/>
+            <a:endParaRPr b="0" i="0" sz="1400" u="none" cap="none" strike="noStrike">
+              <a:solidFill>
+                <a:srgbClr val="000000"/>
+              </a:solidFill>
+              <a:latin typeface="Arial"/>
+              <a:ea typeface="Arial"/>
+              <a:cs typeface="Arial"/>
+              <a:sym typeface="Arial"/>
+            </a:endParaRPr>
           </a:p>
         </p:txBody>
       </p:sp>
@@ -31956,6 +32023,285 @@
 </file>
 
 <file path=ppt/theme/theme1.xml><?xml version="1.0" encoding="utf-8"?>
+<a:theme xmlns:a="http://schemas.openxmlformats.org/drawingml/2006/main" xmlns:r="http://schemas.openxmlformats.org/officeDocument/2006/relationships" name="Office Theme">
+  <a:themeElements>
+    <a:clrScheme name="Office">
+      <a:dk1>
+        <a:srgbClr val="000000"/>
+      </a:dk1>
+      <a:lt1>
+        <a:srgbClr val="FFFFFF"/>
+      </a:lt1>
+      <a:dk2>
+        <a:srgbClr val="1F497D"/>
+      </a:dk2>
+      <a:lt2>
+        <a:srgbClr val="EEECE1"/>
+      </a:lt2>
+      <a:accent1>
+        <a:srgbClr val="4F81BD"/>
+      </a:accent1>
+      <a:accent2>
+        <a:srgbClr val="C0504D"/>
+      </a:accent2>
+      <a:accent3>
+        <a:srgbClr val="9BBB59"/>
+      </a:accent3>
+      <a:accent4>
+        <a:srgbClr val="8064A2"/>
+      </a:accent4>
+      <a:accent5>
+        <a:srgbClr val="4BACC6"/>
+      </a:accent5>
+      <a:accent6>
+        <a:srgbClr val="F79646"/>
+      </a:accent6>
+      <a:hlink>
+        <a:srgbClr val="0000FF"/>
+      </a:hlink>
+      <a:folHlink>
+        <a:srgbClr val="800080"/>
+      </a:folHlink>
+    </a:clrScheme>
+    <a:fontScheme name="Office">
+      <a:majorFont>
+        <a:latin typeface="Arial"/>
+        <a:ea typeface=""/>
+        <a:cs typeface=""/>
+        <a:font script="Jpan" typeface="ＭＳ Ｐゴシック"/>
+        <a:font script="Hang" typeface="맑은 고딕"/>
+        <a:font script="Hans" typeface="宋体"/>
+        <a:font script="Hant" typeface="新細明體"/>
+        <a:font script="Arab" typeface="Times New Roman"/>
+        <a:font script="Hebr" typeface="Times New Roman"/>
+        <a:font script="Thai" typeface="Angsana New"/>
+        <a:font script="Ethi" typeface="Nyala"/>
+        <a:font script="Beng" typeface="Vrinda"/>
+        <a:font script="Gujr" typeface="Shruti"/>
+        <a:font script="Khmr" typeface="MoolBoran"/>
+        <a:font script="Knda" typeface="Tunga"/>
+        <a:font script="Guru" typeface="Raavi"/>
+        <a:font script="Cans" typeface="Euphemia"/>
+        <a:font script="Cher" typeface="Plantagenet Cherokee"/>
+        <a:font script="Yiii" typeface="Microsoft Yi Baiti"/>
+        <a:font script="Tibt" typeface="Microsoft Himalaya"/>
+        <a:font script="Thaa" typeface="MV Boli"/>
+        <a:font script="Deva" typeface="Mangal"/>
+        <a:font script="Telu" typeface="Gautami"/>
+        <a:font script="Taml" typeface="Latha"/>
+        <a:font script="Syrc" typeface="Estrangelo Edessa"/>
+        <a:font script="Orya" typeface="Kalinga"/>
+        <a:font script="Mlym" typeface="Kartika"/>
+        <a:font script="Laoo" typeface="DokChampa"/>
+        <a:font script="Sinh" typeface="Iskoola Pota"/>
+        <a:font script="Mong" typeface="Mongolian Baiti"/>
+        <a:font script="Viet" typeface="Times New Roman"/>
+        <a:font script="Uigh" typeface="Microsoft Uighur"/>
+        <a:font script="Geor" typeface="Sylfaen"/>
+      </a:majorFont>
+      <a:minorFont>
+        <a:latin typeface="Arial"/>
+        <a:ea typeface=""/>
+        <a:cs typeface=""/>
+        <a:font script="Jpan" typeface="ＭＳ Ｐゴシック"/>
+        <a:font script="Hang" typeface="맑은 고딕"/>
+        <a:font script="Hans" typeface="宋体"/>
+        <a:font script="Hant" typeface="新細明體"/>
+        <a:font script="Arab" typeface="Arial"/>
+        <a:font script="Hebr" typeface="Arial"/>
+        <a:font script="Thai" typeface="Cordia New"/>
+        <a:font script="Ethi" typeface="Nyala"/>
+        <a:font script="Beng" typeface="Vrinda"/>
+        <a:font script="Gujr" typeface="Shruti"/>
+        <a:font script="Khmr" typeface="DaunPenh"/>
+        <a:font script="Knda" typeface="Tunga"/>
+        <a:font script="Guru" typeface="Raavi"/>
+        <a:font script="Cans" typeface="Euphemia"/>
+        <a:font script="Cher" typeface="Plantagenet Cherokee"/>
+        <a:font script="Yiii" typeface="Microsoft Yi Baiti"/>
+        <a:font script="Tibt" typeface="Microsoft Himalaya"/>
+        <a:font script="Thaa" typeface="MV Boli"/>
+        <a:font script="Deva" typeface="Mangal"/>
+        <a:font script="Telu" typeface="Gautami"/>
+        <a:font script="Taml" typeface="Latha"/>
+        <a:font script="Syrc" typeface="Estrangelo Edessa"/>
+        <a:font script="Orya" typeface="Kalinga"/>
+        <a:font script="Mlym" typeface="Kartika"/>
+        <a:font script="Laoo" typeface="DokChampa"/>
+        <a:font script="Sinh" typeface="Iskoola Pota"/>
+        <a:font script="Mong" typeface="Mongolian Baiti"/>
+        <a:font script="Viet" typeface="Arial"/>
+        <a:font script="Uigh" typeface="Microsoft Uighur"/>
+        <a:font script="Geor" typeface="Sylfaen"/>
+      </a:minorFont>
+    </a:fontScheme>
+    <a:fmtScheme name="Office">
+      <a:fillStyleLst>
+        <a:solidFill>
+          <a:schemeClr val="phClr"/>
+        </a:solidFill>
+        <a:gradFill rotWithShape="1">
+          <a:gsLst>
+            <a:gs pos="0">
+              <a:schemeClr val="phClr">
+                <a:tint val="50000"/>
+                <a:satMod val="300000"/>
+              </a:schemeClr>
+            </a:gs>
+            <a:gs pos="35000">
+              <a:schemeClr val="phClr">
+                <a:tint val="37000"/>
+                <a:satMod val="300000"/>
+              </a:schemeClr>
+            </a:gs>
+            <a:gs pos="100000">
+              <a:schemeClr val="phClr">
+                <a:tint val="15000"/>
+                <a:satMod val="350000"/>
+              </a:schemeClr>
+            </a:gs>
+          </a:gsLst>
+          <a:lin ang="16200000" scaled="1"/>
+        </a:gradFill>
+        <a:gradFill rotWithShape="1">
+          <a:gsLst>
+            <a:gs pos="0">
+              <a:schemeClr val="phClr">
+                <a:tint val="100000"/>
+                <a:shade val="100000"/>
+                <a:satMod val="130000"/>
+              </a:schemeClr>
+            </a:gs>
+            <a:gs pos="100000">
+              <a:schemeClr val="phClr">
+                <a:tint val="50000"/>
+                <a:shade val="100000"/>
+                <a:satMod val="350000"/>
+              </a:schemeClr>
+            </a:gs>
+          </a:gsLst>
+          <a:lin ang="16200000" scaled="0"/>
+        </a:gradFill>
+      </a:fillStyleLst>
+      <a:lnStyleLst>
+        <a:ln w="9525" cap="flat" cmpd="sng" algn="ctr">
+          <a:solidFill>
+            <a:schemeClr val="phClr">
+              <a:shade val="95000"/>
+              <a:satMod val="105000"/>
+            </a:schemeClr>
+          </a:solidFill>
+          <a:prstDash val="solid"/>
+        </a:ln>
+        <a:ln w="25400" cap="flat" cmpd="sng" algn="ctr">
+          <a:solidFill>
+            <a:schemeClr val="phClr"/>
+          </a:solidFill>
+          <a:prstDash val="solid"/>
+        </a:ln>
+        <a:ln w="38100" cap="flat" cmpd="sng" algn="ctr">
+          <a:solidFill>
+            <a:schemeClr val="phClr"/>
+          </a:solidFill>
+          <a:prstDash val="solid"/>
+        </a:ln>
+      </a:lnStyleLst>
+      <a:effectStyleLst>
+        <a:effectStyle>
+          <a:effectLst>
+            <a:outerShdw blurRad="40000" dist="20000" dir="5400000" rotWithShape="0">
+              <a:srgbClr val="000000">
+                <a:alpha val="38000"/>
+              </a:srgbClr>
+            </a:outerShdw>
+          </a:effectLst>
+        </a:effectStyle>
+        <a:effectStyle>
+          <a:effectLst>
+            <a:outerShdw blurRad="40000" dist="23000" dir="5400000" rotWithShape="0">
+              <a:srgbClr val="000000">
+                <a:alpha val="35000"/>
+              </a:srgbClr>
+            </a:outerShdw>
+          </a:effectLst>
+        </a:effectStyle>
+        <a:effectStyle>
+          <a:effectLst>
+            <a:outerShdw blurRad="40000" dist="23000" dir="5400000" rotWithShape="0">
+              <a:srgbClr val="000000">
+                <a:alpha val="35000"/>
+              </a:srgbClr>
+            </a:outerShdw>
+          </a:effectLst>
+          <a:scene3d>
+            <a:camera prst="orthographicFront">
+              <a:rot lat="0" lon="0" rev="0"/>
+            </a:camera>
+            <a:lightRig rig="threePt" dir="t">
+              <a:rot lat="0" lon="0" rev="1200000"/>
+            </a:lightRig>
+          </a:scene3d>
+          <a:sp3d>
+            <a:bevelT w="63500" h="25400"/>
+          </a:sp3d>
+        </a:effectStyle>
+      </a:effectStyleLst>
+      <a:bgFillStyleLst>
+        <a:solidFill>
+          <a:schemeClr val="phClr"/>
+        </a:solidFill>
+        <a:gradFill rotWithShape="1">
+          <a:gsLst>
+            <a:gs pos="0">
+              <a:schemeClr val="phClr">
+                <a:tint val="40000"/>
+                <a:satMod val="350000"/>
+              </a:schemeClr>
+            </a:gs>
+            <a:gs pos="40000">
+              <a:schemeClr val="phClr">
+                <a:tint val="45000"/>
+                <a:shade val="99000"/>
+                <a:satMod val="350000"/>
+              </a:schemeClr>
+            </a:gs>
+            <a:gs pos="100000">
+              <a:schemeClr val="phClr">
+                <a:shade val="20000"/>
+                <a:satMod val="255000"/>
+              </a:schemeClr>
+            </a:gs>
+          </a:gsLst>
+          <a:path path="circle">
+            <a:fillToRect l="50000" t="-80000" r="50000" b="180000"/>
+          </a:path>
+        </a:gradFill>
+        <a:gradFill rotWithShape="1">
+          <a:gsLst>
+            <a:gs pos="0">
+              <a:schemeClr val="phClr">
+                <a:tint val="80000"/>
+                <a:satMod val="300000"/>
+              </a:schemeClr>
+            </a:gs>
+            <a:gs pos="100000">
+              <a:schemeClr val="phClr">
+                <a:shade val="30000"/>
+                <a:satMod val="200000"/>
+              </a:schemeClr>
+            </a:gs>
+          </a:gsLst>
+          <a:path path="circle">
+            <a:fillToRect l="50000" t="50000" r="50000" b="50000"/>
+          </a:path>
+        </a:gradFill>
+      </a:bgFillStyleLst>
+    </a:fmtScheme>
+  </a:themeElements>
+</a:theme>
+</file>
+
+<file path=ppt/theme/theme2.xml><?xml version="1.0" encoding="utf-8"?>
 <a:theme xmlns:a="http://schemas.openxmlformats.org/drawingml/2006/main" xmlns:r="http://schemas.openxmlformats.org/officeDocument/2006/relationships">
   <a:themeElements>
     <a:clrScheme name="Default">
@@ -32232,283 +32578,4 @@
     </a:fmtScheme>
   </a:themeElements>
 </a:theme>
-</file>
-
-<file path=ppt/theme/theme2.xml><?xml version="1.0" encoding="utf-8"?>
-<a:theme xmlns:a="http://schemas.openxmlformats.org/drawingml/2006/main" xmlns:r="http://schemas.openxmlformats.org/officeDocument/2006/relationships" name="Office Theme">
-  <a:themeElements>
-    <a:clrScheme name="Office">
-      <a:dk1>
-        <a:srgbClr val="000000"/>
-      </a:dk1>
-      <a:lt1>
-        <a:srgbClr val="FFFFFF"/>
-      </a:lt1>
-      <a:dk2>
-        <a:srgbClr val="1F497D"/>
-      </a:dk2>
-      <a:lt2>
-        <a:srgbClr val="EEECE1"/>
-      </a:lt2>
-      <a:accent1>
-        <a:srgbClr val="4F81BD"/>
-      </a:accent1>
-      <a:accent2>
-        <a:srgbClr val="C0504D"/>
-      </a:accent2>
-      <a:accent3>
-        <a:srgbClr val="9BBB59"/>
-      </a:accent3>
-      <a:accent4>
-        <a:srgbClr val="8064A2"/>
-      </a:accent4>
-      <a:accent5>
-        <a:srgbClr val="4BACC6"/>
-      </a:accent5>
-      <a:accent6>
-        <a:srgbClr val="F79646"/>
-      </a:accent6>
-      <a:hlink>
-        <a:srgbClr val="0000FF"/>
-      </a:hlink>
-      <a:folHlink>
-        <a:srgbClr val="800080"/>
-      </a:folHlink>
-    </a:clrScheme>
-    <a:fontScheme name="Office">
-      <a:majorFont>
-        <a:latin typeface="Arial"/>
-        <a:ea typeface=""/>
-        <a:cs typeface=""/>
-        <a:font script="Jpan" typeface="ＭＳ Ｐゴシック"/>
-        <a:font script="Hang" typeface="맑은 고딕"/>
-        <a:font script="Hans" typeface="宋体"/>
-        <a:font script="Hant" typeface="新細明體"/>
-        <a:font script="Arab" typeface="Times New Roman"/>
-        <a:font script="Hebr" typeface="Times New Roman"/>
-        <a:font script="Thai" typeface="Angsana New"/>
-        <a:font script="Ethi" typeface="Nyala"/>
-        <a:font script="Beng" typeface="Vrinda"/>
-        <a:font script="Gujr" typeface="Shruti"/>
-        <a:font script="Khmr" typeface="MoolBoran"/>
-        <a:font script="Knda" typeface="Tunga"/>
-        <a:font script="Guru" typeface="Raavi"/>
-        <a:font script="Cans" typeface="Euphemia"/>
-        <a:font script="Cher" typeface="Plantagenet Cherokee"/>
-        <a:font script="Yiii" typeface="Microsoft Yi Baiti"/>
-        <a:font script="Tibt" typeface="Microsoft Himalaya"/>
-        <a:font script="Thaa" typeface="MV Boli"/>
-        <a:font script="Deva" typeface="Mangal"/>
-        <a:font script="Telu" typeface="Gautami"/>
-        <a:font script="Taml" typeface="Latha"/>
-        <a:font script="Syrc" typeface="Estrangelo Edessa"/>
-        <a:font script="Orya" typeface="Kalinga"/>
-        <a:font script="Mlym" typeface="Kartika"/>
-        <a:font script="Laoo" typeface="DokChampa"/>
-        <a:font script="Sinh" typeface="Iskoola Pota"/>
-        <a:font script="Mong" typeface="Mongolian Baiti"/>
-        <a:font script="Viet" typeface="Times New Roman"/>
-        <a:font script="Uigh" typeface="Microsoft Uighur"/>
-        <a:font script="Geor" typeface="Sylfaen"/>
-      </a:majorFont>
-      <a:minorFont>
-        <a:latin typeface="Arial"/>
-        <a:ea typeface=""/>
-        <a:cs typeface=""/>
-        <a:font script="Jpan" typeface="ＭＳ Ｐゴシック"/>
-        <a:font script="Hang" typeface="맑은 고딕"/>
-        <a:font script="Hans" typeface="宋体"/>
-        <a:font script="Hant" typeface="新細明體"/>
-        <a:font script="Arab" typeface="Arial"/>
-        <a:font script="Hebr" typeface="Arial"/>
-        <a:font script="Thai" typeface="Cordia New"/>
-        <a:font script="Ethi" typeface="Nyala"/>
-        <a:font script="Beng" typeface="Vrinda"/>
-        <a:font script="Gujr" typeface="Shruti"/>
-        <a:font script="Khmr" typeface="DaunPenh"/>
-        <a:font script="Knda" typeface="Tunga"/>
-        <a:font script="Guru" typeface="Raavi"/>
-        <a:font script="Cans" typeface="Euphemia"/>
-        <a:font script="Cher" typeface="Plantagenet Cherokee"/>
-        <a:font script="Yiii" typeface="Microsoft Yi Baiti"/>
-        <a:font script="Tibt" typeface="Microsoft Himalaya"/>
-        <a:font script="Thaa" typeface="MV Boli"/>
-        <a:font script="Deva" typeface="Mangal"/>
-        <a:font script="Telu" typeface="Gautami"/>
-        <a:font script="Taml" typeface="Latha"/>
-        <a:font script="Syrc" typeface="Estrangelo Edessa"/>
-        <a:font script="Orya" typeface="Kalinga"/>
-        <a:font script="Mlym" typeface="Kartika"/>
-        <a:font script="Laoo" typeface="DokChampa"/>
-        <a:font script="Sinh" typeface="Iskoola Pota"/>
-        <a:font script="Mong" typeface="Mongolian Baiti"/>
-        <a:font script="Viet" typeface="Arial"/>
-        <a:font script="Uigh" typeface="Microsoft Uighur"/>
-        <a:font script="Geor" typeface="Sylfaen"/>
-      </a:minorFont>
-    </a:fontScheme>
-    <a:fmtScheme name="Office">
-      <a:fillStyleLst>
-        <a:solidFill>
-          <a:schemeClr val="phClr"/>
-        </a:solidFill>
-        <a:gradFill rotWithShape="1">
-          <a:gsLst>
-            <a:gs pos="0">
-              <a:schemeClr val="phClr">
-                <a:tint val="50000"/>
-                <a:satMod val="300000"/>
-              </a:schemeClr>
-            </a:gs>
-            <a:gs pos="35000">
-              <a:schemeClr val="phClr">
-                <a:tint val="37000"/>
-                <a:satMod val="300000"/>
-              </a:schemeClr>
-            </a:gs>
-            <a:gs pos="100000">
-              <a:schemeClr val="phClr">
-                <a:tint val="15000"/>
-                <a:satMod val="350000"/>
-              </a:schemeClr>
-            </a:gs>
-          </a:gsLst>
-          <a:lin ang="16200000" scaled="1"/>
-        </a:gradFill>
-        <a:gradFill rotWithShape="1">
-          <a:gsLst>
-            <a:gs pos="0">
-              <a:schemeClr val="phClr">
-                <a:tint val="100000"/>
-                <a:shade val="100000"/>
-                <a:satMod val="130000"/>
-              </a:schemeClr>
-            </a:gs>
-            <a:gs pos="100000">
-              <a:schemeClr val="phClr">
-                <a:tint val="50000"/>
-                <a:shade val="100000"/>
-                <a:satMod val="350000"/>
-              </a:schemeClr>
-            </a:gs>
-          </a:gsLst>
-          <a:lin ang="16200000" scaled="0"/>
-        </a:gradFill>
-      </a:fillStyleLst>
-      <a:lnStyleLst>
-        <a:ln w="9525" cap="flat" cmpd="sng" algn="ctr">
-          <a:solidFill>
-            <a:schemeClr val="phClr">
-              <a:shade val="95000"/>
-              <a:satMod val="105000"/>
-            </a:schemeClr>
-          </a:solidFill>
-          <a:prstDash val="solid"/>
-        </a:ln>
-        <a:ln w="25400" cap="flat" cmpd="sng" algn="ctr">
-          <a:solidFill>
-            <a:schemeClr val="phClr"/>
-          </a:solidFill>
-          <a:prstDash val="solid"/>
-        </a:ln>
-        <a:ln w="38100" cap="flat" cmpd="sng" algn="ctr">
-          <a:solidFill>
-            <a:schemeClr val="phClr"/>
-          </a:solidFill>
-          <a:prstDash val="solid"/>
-        </a:ln>
-      </a:lnStyleLst>
-      <a:effectStyleLst>
-        <a:effectStyle>
-          <a:effectLst>
-            <a:outerShdw blurRad="40000" dist="20000" dir="5400000" rotWithShape="0">
-              <a:srgbClr val="000000">
-                <a:alpha val="38000"/>
-              </a:srgbClr>
-            </a:outerShdw>
-          </a:effectLst>
-        </a:effectStyle>
-        <a:effectStyle>
-          <a:effectLst>
-            <a:outerShdw blurRad="40000" dist="23000" dir="5400000" rotWithShape="0">
-              <a:srgbClr val="000000">
-                <a:alpha val="35000"/>
-              </a:srgbClr>
-            </a:outerShdw>
-          </a:effectLst>
-        </a:effectStyle>
-        <a:effectStyle>
-          <a:effectLst>
-            <a:outerShdw blurRad="40000" dist="23000" dir="5400000" rotWithShape="0">
-              <a:srgbClr val="000000">
-                <a:alpha val="35000"/>
-              </a:srgbClr>
-            </a:outerShdw>
-          </a:effectLst>
-          <a:scene3d>
-            <a:camera prst="orthographicFront">
-              <a:rot lat="0" lon="0" rev="0"/>
-            </a:camera>
-            <a:lightRig rig="threePt" dir="t">
-              <a:rot lat="0" lon="0" rev="1200000"/>
-            </a:lightRig>
-          </a:scene3d>
-          <a:sp3d>
-            <a:bevelT w="63500" h="25400"/>
-          </a:sp3d>
-        </a:effectStyle>
-      </a:effectStyleLst>
-      <a:bgFillStyleLst>
-        <a:solidFill>
-          <a:schemeClr val="phClr"/>
-        </a:solidFill>
-        <a:gradFill rotWithShape="1">
-          <a:gsLst>
-            <a:gs pos="0">
-              <a:schemeClr val="phClr">
-                <a:tint val="40000"/>
-                <a:satMod val="350000"/>
-              </a:schemeClr>
-            </a:gs>
-            <a:gs pos="40000">
-              <a:schemeClr val="phClr">
-                <a:tint val="45000"/>
-                <a:shade val="99000"/>
-                <a:satMod val="350000"/>
-              </a:schemeClr>
-            </a:gs>
-            <a:gs pos="100000">
-              <a:schemeClr val="phClr">
-                <a:shade val="20000"/>
-                <a:satMod val="255000"/>
-              </a:schemeClr>
-            </a:gs>
-          </a:gsLst>
-          <a:path path="circle">
-            <a:fillToRect l="50000" t="-80000" r="50000" b="180000"/>
-          </a:path>
-        </a:gradFill>
-        <a:gradFill rotWithShape="1">
-          <a:gsLst>
-            <a:gs pos="0">
-              <a:schemeClr val="phClr">
-                <a:tint val="80000"/>
-                <a:satMod val="300000"/>
-              </a:schemeClr>
-            </a:gs>
-            <a:gs pos="100000">
-              <a:schemeClr val="phClr">
-                <a:shade val="30000"/>
-                <a:satMod val="200000"/>
-              </a:schemeClr>
-            </a:gs>
-          </a:gsLst>
-          <a:path path="circle">
-            <a:fillToRect l="50000" t="50000" r="50000" b="50000"/>
-          </a:path>
-        </a:gradFill>
-      </a:bgFillStyleLst>
-    </a:fmtScheme>
-  </a:themeElements>
-</a:theme>
 </file>
</xml_diff>